<commit_message>
Rewrite deck copy into an academic register
Removes the course-code and slide-range decorations, the title-slide
blurb, and the running-message banner on the agenda slide.

Reworks headings and body copy across all twenty slides so headers read
as nominal academic labels rather than notes to self. Chapter 3's six
limits are recast as Abstraksi berlebih, Reduksionisme, Objektivisme
elitis, Impersonalitas, Rasionalisme terkodifikasi, and Imperialisme
kultural. Family metaphors become klasifikasi, verdict labels move to
Ambivalen, Menolak pembanding, Menolak prosedur, and Relativistik, and
the title-slide reference now follows standard citation form.

Co-Authored-By: Claude Opus 5 <noreply@anthropic.com>
Claude-Session: https://claude.ai/code/session_01AfH2yvsTon6btbkPiZnykT
</commit_message>
<xml_diff>
--- a/business-ethics/Evaluating-Business-Ethics-Hilirisasi-Nikel.pptx
+++ b/business-ethics/Evaluating-Business-Ethics-Hilirisasi-Nikel.pptx
@@ -3571,7 +3571,7 @@
                 <a:ea typeface="Calibri" pitchFamily="34" charset="-122"/>
                 <a:cs typeface="Calibri" pitchFamily="34" charset="-120"/>
               </a:rPr>
-              <a:t>BUSINESS ETHICS FOR SUSTAINABILITY   |   MAN5522   |   MBA UGM</a:t>
+              <a:t>BUSINESS ETHICS FOR SUSTAINABILITY</a:t>
             </a:r>
             <a:endParaRPr lang="en-US" sz="1050" dirty="0"/>
           </a:p>
@@ -3686,8 +3686,8 @@
         </p:nvSpPr>
         <p:spPr>
           <a:xfrm>
-            <a:off x="566928" y="3794760"/>
-            <a:ext cx="6858000" cy="640080"/>
+            <a:off x="566928" y="4315968"/>
+            <a:ext cx="4572000" cy="685800"/>
           </a:xfrm>
           <a:prstGeom prst="rect">
             <a:avLst/>
@@ -3706,40 +3706,18 @@
               <a:buNone/>
             </a:pPr>
             <a:r>
-              <a:rPr lang="en-US" sz="1350" dirty="0">
-                <a:solidFill>
-                  <a:srgbClr val="C6CFD8"/>
-                </a:solidFill>
-                <a:latin typeface="Calibri" pitchFamily="34" charset="0"/>
-                <a:ea typeface="Calibri" pitchFamily="34" charset="-122"/>
-                <a:cs typeface="Calibri" pitchFamily="34" charset="-120"/>
-              </a:rPr>
-              <a:t>Sembilan teori etika normatif dari Bab 3, lalu diuji pada satu kebijakan yang masih berjalan: hilirisasi nikel Indonesia.</a:t>
-            </a:r>
-            <a:endParaRPr lang="en-US" sz="1350" dirty="0"/>
-          </a:p>
-        </p:txBody>
-      </p:sp>
-      <p:sp>
-        <p:nvSpPr>
-          <p:cNvPr id="34" name="Text 32"/>
-          <p:cNvSpPr txBox="1"/>
-          <p:nvPr/>
-        </p:nvSpPr>
-        <p:spPr>
-          <a:xfrm>
-            <a:off x="566928" y="4892040"/>
-            <a:ext cx="4572000" cy="685800"/>
-          </a:xfrm>
-          <a:prstGeom prst="rect">
-            <a:avLst/>
-          </a:prstGeom>
-          <a:noFill/>
-          <a:ln/>
-        </p:spPr>
-        <p:txBody>
-          <a:bodyPr wrap="square" lIns="0" tIns="0" rIns="0" bIns="0" rtlCol="0" anchor="t"/>
-          <a:lstStyle/>
+              <a:rPr lang="en-US" sz="1500" b="1" dirty="0">
+                <a:solidFill>
+                  <a:srgbClr val="FFFFFF"/>
+                </a:solidFill>
+                <a:latin typeface="Cambria" pitchFamily="34" charset="0"/>
+                <a:ea typeface="Cambria" pitchFamily="34" charset="-122"/>
+                <a:cs typeface="Cambria" pitchFamily="34" charset="-120"/>
+              </a:rPr>
+              <a:t>Aslih Abnuri</a:t>
+            </a:r>
+            <a:endParaRPr lang="en-US" sz="1500" dirty="0"/>
+          </a:p>
           <a:p>
             <a:pPr indent="0" marL="0">
               <a:lnSpc>
@@ -3748,43 +3726,23 @@
               <a:buNone/>
             </a:pPr>
             <a:r>
-              <a:rPr lang="en-US" sz="1500" b="1" dirty="0">
-                <a:solidFill>
-                  <a:srgbClr val="FFFFFF"/>
-                </a:solidFill>
-                <a:latin typeface="Cambria" pitchFamily="34" charset="0"/>
-                <a:ea typeface="Cambria" pitchFamily="34" charset="-122"/>
-                <a:cs typeface="Cambria" pitchFamily="34" charset="-120"/>
-              </a:rPr>
-              <a:t>Aslih Abnuri</a:t>
+              <a:rPr lang="en-US" sz="1150" dirty="0">
+                <a:solidFill>
+                  <a:srgbClr val="97A3AE"/>
+                </a:solidFill>
+                <a:latin typeface="Calibri" pitchFamily="34" charset="0"/>
+                <a:ea typeface="Calibri" pitchFamily="34" charset="-122"/>
+                <a:cs typeface="Calibri" pitchFamily="34" charset="-120"/>
+              </a:rPr>
+              <a:t>25/574338/PEK/31801</a:t>
             </a:r>
             <a:endParaRPr lang="en-US" sz="1500" dirty="0"/>
           </a:p>
-          <a:p>
-            <a:pPr indent="0" marL="0">
-              <a:lnSpc>
-                <a:spcPct val="120000"/>
-              </a:lnSpc>
-              <a:buNone/>
-            </a:pPr>
-            <a:r>
-              <a:rPr lang="en-US" sz="1150" dirty="0">
-                <a:solidFill>
-                  <a:srgbClr val="97A3AE"/>
-                </a:solidFill>
-                <a:latin typeface="Calibri" pitchFamily="34" charset="0"/>
-                <a:ea typeface="Calibri" pitchFamily="34" charset="-122"/>
-                <a:cs typeface="Calibri" pitchFamily="34" charset="-120"/>
-              </a:rPr>
-              <a:t>25/574338/PEK/31801</a:t>
-            </a:r>
-            <a:endParaRPr lang="en-US" sz="1500" dirty="0"/>
-          </a:p>
-        </p:txBody>
-      </p:sp>
-      <p:sp>
-        <p:nvSpPr>
-          <p:cNvPr id="35" name="Text 33"/>
+        </p:txBody>
+      </p:sp>
+      <p:sp>
+        <p:nvSpPr>
+          <p:cNvPr id="34" name="Text 32"/>
           <p:cNvSpPr txBox="1"/>
           <p:nvPr/>
         </p:nvSpPr>
@@ -3818,7 +3776,7 @@
                 <a:ea typeface="Calibri" pitchFamily="34" charset="-122"/>
                 <a:cs typeface="Calibri" pitchFamily="34" charset="-120"/>
               </a:rPr>
-              <a:t>Rujukan: Crane, Matten, Glozer, dan Spence (2019), Business Ethics: Managing Corporate Citizenship and Sustainability in the Age of Globalization, edisi kelima, Oxford University Press, Bab 3.</a:t>
+              <a:t>Crane, A., Matten, D., Glozer, S., dan Spence, L. (2019). Business Ethics: Managing Corporate Citizenship and Sustainability in the Age of Globalization. Edisi kelima. Oxford: Oxford University Press, Bab 3.</a:t>
             </a:r>
             <a:endParaRPr lang="en-US" sz="950" dirty="0"/>
           </a:p>
@@ -3970,7 +3928,7 @@
                 <a:ea typeface="Calibri" pitchFamily="34" charset="-122"/>
                 <a:cs typeface="Calibri" pitchFamily="34" charset="-120"/>
               </a:rPr>
-              <a:t>Pertanyaannya bergeser dari benar atau salah menjadi susunan seperti apa yang pantas kita sepakati bersama.</a:t>
+              <a:t>Pertanyaannya bergeser dari benar atau salah menjadi susunan seperti apa yang layak disepakati bersama.</a:t>
             </a:r>
             <a:endParaRPr lang="en-US" sz="1250" dirty="0"/>
           </a:p>
@@ -4333,7 +4291,7 @@
                 <a:ea typeface="Calibri" pitchFamily="34" charset="-122"/>
                 <a:cs typeface="Calibri" pitchFamily="34" charset="-120"/>
               </a:rPr>
-              <a:t>Adil pada prosesnya. Siapa yang boleh ikut memutuskan dan dengan cara apa.</a:t>
+              <a:t>Keadilan pada prosesnya. Siapa yang berhak turut memutuskan dan melalui mekanisme apa.</a:t>
             </a:r>
             <a:endParaRPr lang="en-US" sz="1150" dirty="0"/>
           </a:p>
@@ -4441,7 +4399,7 @@
                 <a:ea typeface="Calibri" pitchFamily="34" charset="-122"/>
                 <a:cs typeface="Calibri" pitchFamily="34" charset="-120"/>
               </a:rPr>
-              <a:t>Adil pada hasilnya. Ke mana manfaat mengalir dan siapa menanggung bebannya.</a:t>
+              <a:t>Keadilan pada hasilnya. Ke mana manfaat mengalir dan siapa yang menanggung bebannya.</a:t>
             </a:r>
             <a:endParaRPr lang="en-US" sz="1150" dirty="0"/>
           </a:p>
@@ -5058,7 +5016,7 @@
                 <a:ea typeface="Calibri" pitchFamily="34" charset="-122"/>
                 <a:cs typeface="Calibri" pitchFamily="34" charset="-120"/>
               </a:rPr>
-              <a:t>05   TITIK BALIK</a:t>
+              <a:t>05   EVALUASI KRITIS</a:t>
             </a:r>
             <a:endParaRPr lang="en-US" sz="1000" dirty="0"/>
           </a:p>
@@ -5097,7 +5055,7 @@
                 <a:ea typeface="Cambria" pitchFamily="34" charset="-122"/>
                 <a:cs typeface="Cambria" pitchFamily="34" charset="-120"/>
               </a:rPr>
-              <a:t>Enam keberatan atas teori modernis</a:t>
+              <a:t>Enam keterbatasan teori modernis Barat</a:t>
             </a:r>
             <a:endParaRPr lang="en-US" sz="2800" dirty="0"/>
           </a:p>
@@ -5139,7 +5097,7 @@
                 <a:ea typeface="Calibri" pitchFamily="34" charset="-122"/>
                 <a:cs typeface="Calibri" pitchFamily="34" charset="-120"/>
               </a:rPr>
-              <a:t>Keberatan inilah yang melahirkan empat teori alternatif pada bagian berikutnya.</a:t>
+              <a:t>Keberatan ini menjadi dasar kemunculan empat teori alternatif yang dibahas berikutnya.</a:t>
             </a:r>
             <a:endParaRPr lang="en-US" sz="1250" dirty="0"/>
           </a:p>
@@ -5274,7 +5232,7 @@
                 <a:ea typeface="Cambria" pitchFamily="34" charset="-122"/>
                 <a:cs typeface="Cambria" pitchFamily="34" charset="-120"/>
               </a:rPr>
-              <a:t>Terlalu abstrak</a:t>
+              <a:t>Abstraksi berlebih</a:t>
             </a:r>
             <a:endParaRPr lang="en-US" sz="1500" dirty="0"/>
           </a:p>
@@ -5316,7 +5274,7 @@
                 <a:ea typeface="Calibri" pitchFamily="34" charset="-122"/>
                 <a:cs typeface="Calibri" pitchFamily="34" charset="-120"/>
               </a:rPr>
-              <a:t>Prinsipnya melayang jauh di atas persoalan yang benar-benar dihadapi manajer setiap hari.</a:t>
+              <a:t>Prinsipnya beroperasi pada tataran yang jauh dari persoalan konkret yang dihadapi manajer.</a:t>
             </a:r>
             <a:endParaRPr lang="en-US" sz="1150" dirty="0"/>
           </a:p>
@@ -5451,7 +5409,7 @@
                 <a:ea typeface="Cambria" pitchFamily="34" charset="-122"/>
                 <a:cs typeface="Cambria" pitchFamily="34" charset="-120"/>
               </a:rPr>
-              <a:t>Terlalu reduksionis</a:t>
+              <a:t>Reduksionisme</a:t>
             </a:r>
             <a:endParaRPr lang="en-US" sz="1500" dirty="0"/>
           </a:p>
@@ -5493,7 +5451,7 @@
                 <a:ea typeface="Calibri" pitchFamily="34" charset="-122"/>
                 <a:cs typeface="Calibri" pitchFamily="34" charset="-120"/>
               </a:rPr>
-              <a:t>Setiap teori memusatkan perhatian pada satu aspek moralitas, lalu memperlakukannya seolah itu keseluruhan.</a:t>
+              <a:t>Setiap teori menonjolkan satu dimensi moralitas dan memperlakukannya sebagai keseluruhan.</a:t>
             </a:r>
             <a:endParaRPr lang="en-US" sz="1150" dirty="0"/>
           </a:p>
@@ -5628,7 +5586,7 @@
                 <a:ea typeface="Cambria" pitchFamily="34" charset="-122"/>
                 <a:cs typeface="Cambria" pitchFamily="34" charset="-120"/>
               </a:rPr>
-              <a:t>Terlalu objektif dan elitis</a:t>
+              <a:t>Objektivisme elitis</a:t>
             </a:r>
             <a:endParaRPr lang="en-US" sz="1500" dirty="0"/>
           </a:p>
@@ -5670,7 +5628,7 @@
                 <a:ea typeface="Calibri" pitchFamily="34" charset="-122"/>
                 <a:cs typeface="Calibri" pitchFamily="34" charset="-120"/>
               </a:rPr>
-              <a:t>Kebenaran moral ditentukan para ahli lewat deduksi, bukan oleh orang yang menjalani situasinya.</a:t>
+              <a:t>Kebenaran moral ditentukan melalui deduksi ahli, bukan melalui pengalaman pihak yang terlibat.</a:t>
             </a:r>
             <a:endParaRPr lang="en-US" sz="1150" dirty="0"/>
           </a:p>
@@ -5805,7 +5763,7 @@
                 <a:ea typeface="Cambria" pitchFamily="34" charset="-122"/>
                 <a:cs typeface="Cambria" pitchFamily="34" charset="-120"/>
               </a:rPr>
-              <a:t>Terlalu impersonal</a:t>
+              <a:t>Impersonalitas</a:t>
             </a:r>
             <a:endParaRPr lang="en-US" sz="1500" dirty="0"/>
           </a:p>
@@ -5847,7 +5805,7 @@
                 <a:ea typeface="Calibri" pitchFamily="34" charset="-122"/>
                 <a:cs typeface="Calibri" pitchFamily="34" charset="-120"/>
               </a:rPr>
-              <a:t>Ikatan pribadi dan tanggung jawab pada orang tertentu justru dianggap mengganggu penilaian.</a:t>
+              <a:t>Ikatan personal dan tanggung jawab pada pihak tertentu diposisikan sebagai pengganggu penilaian.</a:t>
             </a:r>
             <a:endParaRPr lang="en-US" sz="1150" dirty="0"/>
           </a:p>
@@ -5982,7 +5940,7 @@
                 <a:ea typeface="Cambria" pitchFamily="34" charset="-122"/>
                 <a:cs typeface="Cambria" pitchFamily="34" charset="-120"/>
               </a:rPr>
-              <a:t>Terlalu rasional dan terkodifikasi</a:t>
+              <a:t>Rasionalisme terkodifikasi</a:t>
             </a:r>
             <a:endParaRPr lang="en-US" sz="1500" dirty="0"/>
           </a:p>
@@ -6024,7 +5982,7 @@
                 <a:ea typeface="Calibri" pitchFamily="34" charset="-122"/>
                 <a:cs typeface="Calibri" pitchFamily="34" charset="-120"/>
               </a:rPr>
-              <a:t>Perasaan, empati, dan dorongan moral dipandang rendah, padahal itu yang sering menggerakkan tindakan.</a:t>
+              <a:t>Peran perasaan, empati, dan dorongan moral diabaikan dalam perumusan penilaian etis.</a:t>
             </a:r>
             <a:endParaRPr lang="en-US" sz="1150" dirty="0"/>
           </a:p>
@@ -6159,7 +6117,7 @@
                 <a:ea typeface="Cambria" pitchFamily="34" charset="-122"/>
                 <a:cs typeface="Cambria" pitchFamily="34" charset="-120"/>
               </a:rPr>
-              <a:t>Terlalu imperialis</a:t>
+              <a:t>Imperialisme kultural</a:t>
             </a:r>
             <a:endParaRPr lang="en-US" sz="1500" dirty="0"/>
           </a:p>
@@ -6201,7 +6159,7 @@
                 <a:ea typeface="Calibri" pitchFamily="34" charset="-122"/>
                 <a:cs typeface="Calibri" pitchFamily="34" charset="-120"/>
               </a:rPr>
-              <a:t>Pengalaman dan tradisi berpikir Barat diangkat menjadi ukuran yang seolah berlaku bagi semua kebudayaan.</a:t>
+              <a:t>Pengalaman dan tradisi intelektual Barat diposisikan sebagai ukuran yang berlaku universal.</a:t>
             </a:r>
             <a:endParaRPr lang="en-US" sz="1150" dirty="0"/>
           </a:p>
@@ -6267,7 +6225,7 @@
                 <a:ea typeface="Calibri" pitchFamily="34" charset="-122"/>
                 <a:cs typeface="Calibri" pitchFamily="34" charset="-120"/>
               </a:rPr>
-              <a:t>Teori alternatif tidak menggantikan teori modernis. Ia menambahkan pertanyaan yang tidak pernah diajukan, yaitu tentang karakter pelaku, relasi yang terlibat, prosedur perumusan norma, dan pilihan kata yang dipakai.</a:t>
+              <a:t>Teori alternatif tidak menggantikan teori modernis, melainkan menambahkan dimensi penilaian yang belum tercakup: karakter pelaku, relasi antarpihak, prosedur perumusan norma, dan pilihan istilah.</a:t>
             </a:r>
             <a:endParaRPr lang="en-US" sz="1150" dirty="0"/>
           </a:p>
@@ -6458,7 +6416,7 @@
                 <a:ea typeface="Calibri" pitchFamily="34" charset="-122"/>
                 <a:cs typeface="Calibri" pitchFamily="34" charset="-120"/>
               </a:rPr>
-              <a:t>Yang dinilai bergeser dari tindakan ke karakter pelaku dan ke relasi di antara pihak yang terlibat.</a:t>
+              <a:t>Objek penilaian bergeser dari tindakan ke karakter pelaku dan ke relasi antarpihak yang terlibat.</a:t>
             </a:r>
             <a:endParaRPr lang="en-US" sz="1250" dirty="0"/>
           </a:p>
@@ -6632,7 +6590,7 @@
                 <a:ea typeface="Cambria" pitchFamily="34" charset="-122"/>
                 <a:cs typeface="Cambria" pitchFamily="34" charset="-120"/>
               </a:rPr>
-              <a:t>Pelaku seperti apa yang pantas disebut baik pada posisi ini?</a:t>
+              <a:t>Pelaku seperti apa yang layak disebut baik pada posisi ini?</a:t>
             </a:r>
             <a:endParaRPr lang="en-US" sz="1350" dirty="0"/>
           </a:p>
@@ -6794,7 +6752,7 @@
                 <a:ea typeface="Calibri" pitchFamily="34" charset="-122"/>
                 <a:cs typeface="Calibri" pitchFamily="34" charset="-120"/>
               </a:rPr>
-              <a:t>DALAM KONTEKS BISNIS</a:t>
+              <a:t>PENERAPAN DALAM BISNIS</a:t>
             </a:r>
             <a:endParaRPr lang="en-US" sz="950" dirty="0"/>
           </a:p>
@@ -6875,7 +6833,7 @@
                 <a:ea typeface="Calibri" pitchFamily="34" charset="-122"/>
                 <a:cs typeface="Calibri" pitchFamily="34" charset="-120"/>
               </a:rPr>
-              <a:t>BATASNYA</a:t>
+              <a:t>KETERBATASAN</a:t>
             </a:r>
             <a:endParaRPr lang="en-US" sz="950" dirty="0"/>
           </a:p>
@@ -7253,7 +7211,7 @@
                 <a:ea typeface="Calibri" pitchFamily="34" charset="-122"/>
                 <a:cs typeface="Calibri" pitchFamily="34" charset="-120"/>
               </a:rPr>
-              <a:t>YANG DITUNTUT</a:t>
+              <a:t>TUNTUTAN NORMATIF</a:t>
             </a:r>
             <a:endParaRPr lang="en-US" sz="950" dirty="0"/>
           </a:p>
@@ -7334,7 +7292,7 @@
                 <a:ea typeface="Calibri" pitchFamily="34" charset="-122"/>
                 <a:cs typeface="Calibri" pitchFamily="34" charset="-120"/>
               </a:rPr>
-              <a:t>BATASNYA</a:t>
+              <a:t>KETERBATASAN</a:t>
             </a:r>
             <a:endParaRPr lang="en-US" sz="950" dirty="0"/>
           </a:p>
@@ -7376,7 +7334,7 @@
                 <a:ea typeface="Calibri" pitchFamily="34" charset="-122"/>
                 <a:cs typeface="Calibri" pitchFamily="34" charset="-120"/>
               </a:rPr>
-              <a:t>Mendahulukan yang dekat berisiko mengabaikan pihak jauh, dan kriteria kepedulian sulit diaudit dengan cara yang sama.</a:t>
+              <a:t>Prioritas pada pihak terdekat berisiko mengabaikan pihak jauh, dan kriteria kepedulian sulit diaudit secara seragam.</a:t>
             </a:r>
             <a:endParaRPr lang="en-US" sz="1150" dirty="0"/>
           </a:p>
@@ -7606,7 +7564,7 @@
                 <a:ea typeface="Calibri" pitchFamily="34" charset="-122"/>
                 <a:cs typeface="Calibri" pitchFamily="34" charset="-120"/>
               </a:rPr>
-              <a:t>Yang dinilai bergeser lagi, kali ini ke prosedur perumusan norma dan ke bahasa yang dipakai membenarkannya.</a:t>
+              <a:t>Objek penilaian bergeser ke prosedur perumusan norma dan ke bahasa yang dipakai untuk membenarkannya.</a:t>
             </a:r>
             <a:endParaRPr lang="en-US" sz="1250" dirty="0"/>
           </a:p>
@@ -8023,7 +7981,7 @@
                 <a:ea typeface="Calibri" pitchFamily="34" charset="-122"/>
                 <a:cs typeface="Calibri" pitchFamily="34" charset="-120"/>
               </a:rPr>
-              <a:t>TUJUANNYA</a:t>
+              <a:t>ORIENTASI</a:t>
             </a:r>
             <a:endParaRPr lang="en-US" sz="950" dirty="0"/>
           </a:p>
@@ -8362,7 +8320,7 @@
                 <a:ea typeface="Calibri" pitchFamily="34" charset="-122"/>
                 <a:cs typeface="Calibri" pitchFamily="34" charset="-120"/>
               </a:rPr>
-              <a:t>Mendahulukan dorongan moral dan perasaan daripada perhitungan rasional. Yang menggerakkan orang berbuat benar sering firasat.</a:t>
+              <a:t>Dorongan moral dan perasaan didahulukan atas perhitungan rasional. Tindakan etis kerap digerakkan oleh intuisi, bukan kalkulasi.</a:t>
             </a:r>
             <a:endParaRPr lang="en-US" sz="1150" dirty="0"/>
           </a:p>
@@ -8401,7 +8359,7 @@
                 <a:ea typeface="Calibri" pitchFamily="34" charset="-122"/>
                 <a:cs typeface="Calibri" pitchFamily="34" charset="-120"/>
               </a:rPr>
-              <a:t>KRITIK PADA ORGANISASI</a:t>
+              <a:t>KRITIK TERHADAP ORGANISASI</a:t>
             </a:r>
             <a:endParaRPr lang="en-US" sz="950" dirty="0"/>
           </a:p>
@@ -8482,7 +8440,7 @@
                 <a:ea typeface="Calibri" pitchFamily="34" charset="-122"/>
                 <a:cs typeface="Calibri" pitchFamily="34" charset="-120"/>
               </a:rPr>
-              <a:t>SIKAP YANG DIANJURKAN</a:t>
+              <a:t>IMPLIKASI SIKAP</a:t>
             </a:r>
             <a:endParaRPr lang="en-US" sz="950" dirty="0"/>
           </a:p>
@@ -8524,7 +8482,7 @@
                 <a:ea typeface="Calibri" pitchFamily="34" charset="-122"/>
                 <a:cs typeface="Calibri" pitchFamily="34" charset="-120"/>
               </a:rPr>
-              <a:t>Mempertanyakan bahasa dan asumsi yang sudah dianggap wajar, lalu bertindak pada skala lokal tempat akibatnya terasa.</a:t>
+              <a:t>Mempertanyakan bahasa dan asumsi yang telah dianggap wajar, lalu bertindak pada skala lokal tempat akibatnya dirasakan.</a:t>
             </a:r>
             <a:endParaRPr lang="en-US" sz="1150" dirty="0"/>
           </a:p>
@@ -8673,7 +8631,7 @@
                 <a:ea typeface="Calibri" pitchFamily="34" charset="-122"/>
                 <a:cs typeface="Calibri" pitchFamily="34" charset="-120"/>
               </a:rPr>
-              <a:t>07   JEMBATAN KE KASUS</a:t>
+              <a:t>07   SINTESIS KERANGKA</a:t>
             </a:r>
             <a:endParaRPr lang="en-US" sz="1000" dirty="0"/>
           </a:p>
@@ -8712,7 +8670,7 @@
                 <a:ea typeface="Cambria" pitchFamily="34" charset="-122"/>
                 <a:cs typeface="Cambria" pitchFamily="34" charset="-120"/>
               </a:rPr>
-              <a:t>Sembilan pertanyaan, satu daftar periksa</a:t>
+              <a:t>Sembilan pertanyaan penilaian</a:t>
             </a:r>
             <a:endParaRPr lang="en-US" sz="2800" dirty="0"/>
           </a:p>
@@ -8754,7 +8712,7 @@
                 <a:ea typeface="Calibri" pitchFamily="34" charset="-122"/>
                 <a:cs typeface="Calibri" pitchFamily="34" charset="-120"/>
               </a:rPr>
-              <a:t>Tidak ada teori yang memberi jawaban lengkap. Yang dicari bukan jawaban tunggal, melainkan pertimbangan yang paling kuat menanggung beban argumen.</a:t>
+              <a:t>Tidak ada teori yang memberikan jawaban lengkap. Yang dicari bukan jawaban tunggal, melainkan pertimbangan yang paling kuat menanggung beban argumen.</a:t>
             </a:r>
             <a:endParaRPr lang="en-US" sz="1250" dirty="0"/>
           </a:p>
@@ -9102,7 +9060,7 @@
                 <a:ea typeface="Calibri" pitchFamily="34" charset="-122"/>
                 <a:cs typeface="Calibri" pitchFamily="34" charset="-120"/>
               </a:rPr>
-              <a:t>Bila seluruh akibat diagregasi, apakah hasilnya positif? Apakah act dan rule sepakat?</a:t>
+              <a:t>Bila seluruh akibat diagregasi, apakah hasilnya positif, dan apakah act dan rule sejalan?</a:t>
             </a:r>
             <a:endParaRPr lang="en-US" sz="1100" dirty="0"/>
           </a:p>
@@ -9798,7 +9756,7 @@
                 <a:ea typeface="Calibri" pitchFamily="34" charset="-122"/>
                 <a:cs typeface="Calibri" pitchFamily="34" charset="-120"/>
               </a:rPr>
-              <a:t>Bagaimana pelaku berkarakter baik bertindak di posisi ini, dan dibandingkan dengan standar mana?</a:t>
+              <a:t>Bagaimana pelaku berkarakter baik bertindak di posisi ini, dan diukur terhadap standar yang mana?</a:t>
             </a:r>
             <a:endParaRPr lang="en-US" sz="1100" dirty="0"/>
           </a:p>
@@ -10389,7 +10347,7 @@
                 <a:ea typeface="Calibri" pitchFamily="34" charset="-122"/>
                 <a:cs typeface="Calibri" pitchFamily="34" charset="-120"/>
               </a:rPr>
-              <a:t>Inilah pendekatan pluralis yang dianjurkan Bab 3. Sembilan penilaian atas satu rangkaian fakta yang identik, lalu kita lihat ke mana mayoritasnya bermuara.</a:t>
+              <a:t>Pendekatan pluralis yang dianjurkan Bab 3 menghasilkan sembilan penilaian atas rangkaian fakta yang identik, untuk kemudian dilihat arah konvergensinya.</a:t>
             </a:r>
             <a:endParaRPr lang="en-US" sz="1150" dirty="0"/>
           </a:p>
@@ -10580,7 +10538,7 @@
                 <a:ea typeface="Calibri" pitchFamily="34" charset="-122"/>
                 <a:cs typeface="Calibri" pitchFamily="34" charset="-120"/>
               </a:rPr>
-              <a:t>Satu instrumen regulasi yang mengubah struktur industri nikel nasional, dan menimbulkan sengketa di dua arah sekaligus.</a:t>
+              <a:t>Satu instrumen regulasi yang mengubah struktur industri nikel nasional sekaligus menimbulkan sengketa di dua arah.</a:t>
             </a:r>
             <a:endParaRPr lang="en-US" sz="1250" dirty="0"/>
           </a:p>
@@ -11750,7 +11708,7 @@
                 <a:ea typeface="Calibri" pitchFamily="34" charset="-122"/>
                 <a:cs typeface="Calibri" pitchFamily="34" charset="-120"/>
               </a:rPr>
-              <a:t>Kasus ini dipilih karena strukturnya khas: manfaatnya besar, terukur, dan terkonsentrasi, sedangkan bebannya tersebar, tertunda, dan sulit dikuantifikasi. Persis jenis persoalan yang tidak selesai dengan satu kriteria penilaian.</a:t>
+              <a:t>Kasus ini dipilih karena strukturnya khas: manfaatnya besar, terukur, dan terkonsentrasi, sedangkan bebannya tersebar, tertunda, dan sulit dikuantifikasi. Persoalan dengan struktur demikian tidak dapat diselesaikan melalui kriteria penilaian tunggal.</a:t>
             </a:r>
             <a:endParaRPr lang="en-US" sz="1200" dirty="0"/>
           </a:p>
@@ -11980,7 +11938,7 @@
                 <a:ea typeface="Calibri" pitchFamily="34" charset="-122"/>
                 <a:cs typeface="Calibri" pitchFamily="34" charset="-120"/>
               </a:rPr>
-              <a:t>Kedua kolom bersandar pada data resmi yang sama sahnya. Yang disengketakan bukan faktanya, melainkan kriteria penilaiannya.</a:t>
+              <a:t>Kedua kolom bersandar pada data resmi yang sama sahnya. Yang disengketakan bukan faktanya, melainkan kriteria penilaian yang dipakai.</a:t>
             </a:r>
             <a:endParaRPr lang="en-US" sz="1250" dirty="0"/>
           </a:p>
@@ -12975,7 +12933,7 @@
                 <a:ea typeface="Cambria" pitchFamily="34" charset="-122"/>
                 <a:cs typeface="Cambria" pitchFamily="34" charset="-120"/>
               </a:rPr>
-              <a:t>Lima lensa modernis atas kebijakan ini</a:t>
+              <a:t>Penilaian berdasarkan lima teori modernis</a:t>
             </a:r>
             <a:endParaRPr lang="en-US" sz="2800" dirty="0"/>
           </a:p>
@@ -13017,7 +12975,7 @@
                 <a:ea typeface="Calibri" pitchFamily="34" charset="-122"/>
                 <a:cs typeface="Calibri" pitchFamily="34" charset="-120"/>
               </a:rPr>
-              <a:t>Penilaian berbasis akibat dan berbasis prinsip, dengan putusan yang ternyata tidak seragam.</a:t>
+              <a:t>Penilaian berbasis akibat dan berbasis prinsip menghasilkan kesimpulan yang tidak seragam.</a:t>
             </a:r>
             <a:endParaRPr lang="en-US" sz="1250" dirty="0"/>
           </a:p>
@@ -13455,7 +13413,7 @@
                 <a:ea typeface="Calibri" pitchFamily="34" charset="-122"/>
                 <a:cs typeface="Calibri" pitchFamily="34" charset="-120"/>
               </a:rPr>
-              <a:t>TERBELAH</a:t>
+              <a:t>AMBIVALEN</a:t>
             </a:r>
             <a:endParaRPr lang="en-US" sz="900" dirty="0"/>
           </a:p>
@@ -14256,7 +14214,7 @@
                 <a:ea typeface="Calibri" pitchFamily="34" charset="-122"/>
                 <a:cs typeface="Calibri" pitchFamily="34" charset="-120"/>
               </a:rPr>
-              <a:t>Dua teori sekeluarga menghasilkan kesimpulan berbeda, dan pemisahnya semata unit analisis: satu tindakan, atau kelas tindakan.</a:t>
+              <a:t>Dua teori dalam klasifikasi yang sama menghasilkan kesimpulan berbeda, dan pembedanya terletak pada unit analisis: tindakan tunggal atau kelas tindakan.</a:t>
             </a:r>
             <a:endParaRPr lang="en-US" sz="900" dirty="0"/>
           </a:p>
@@ -14405,7 +14363,7 @@
                 <a:ea typeface="Cambria" pitchFamily="34" charset="-122"/>
                 <a:cs typeface="Cambria" pitchFamily="34" charset="-120"/>
               </a:rPr>
-              <a:t>Empat lensa alternatif atas kasus sama</a:t>
+              <a:t>Penilaian berdasarkan empat teori alternatif</a:t>
             </a:r>
             <a:endParaRPr lang="en-US" sz="2800" dirty="0"/>
           </a:p>
@@ -14447,7 +14405,7 @@
                 <a:ea typeface="Calibri" pitchFamily="34" charset="-122"/>
                 <a:cs typeface="Calibri" pitchFamily="34" charset="-120"/>
               </a:rPr>
-              <a:t>Penilaian bergeser ke karakter pelaku, relasi, prosedur, dan bahasa. Tidak satu pun mengubah faktanya.</a:t>
+              <a:t>Penilaian bergeser ke karakter pelaku, relasi, prosedur, dan bahasa, tanpa mengubah rangkaian faktanya.</a:t>
             </a:r>
             <a:endParaRPr lang="en-US" sz="1250" dirty="0"/>
           </a:p>
@@ -14645,7 +14603,7 @@
                 <a:ea typeface="Calibri" pitchFamily="34" charset="-122"/>
                 <a:cs typeface="Calibri" pitchFamily="34" charset="-120"/>
               </a:rPr>
-              <a:t>MENOLAK FRAMING</a:t>
+              <a:t>MENOLAK PEMBANDING</a:t>
             </a:r>
             <a:endParaRPr lang="en-US" sz="900" dirty="0"/>
           </a:p>
@@ -14684,7 +14642,7 @@
                 <a:ea typeface="Cambria" pitchFamily="34" charset="-122"/>
                 <a:cs typeface="Cambria" pitchFamily="34" charset="-120"/>
               </a:rPr>
-              <a:t>Berkarakter baik diukur dari standar yang mana?</a:t>
+              <a:t>Standar pembanding mana yang seharusnya dipakai?</a:t>
             </a:r>
             <a:endParaRPr lang="en-US" sz="1200" dirty="0"/>
           </a:p>
@@ -14963,7 +14921,7 @@
                 <a:ea typeface="Cambria" pitchFamily="34" charset="-122"/>
                 <a:cs typeface="Cambria" pitchFamily="34" charset="-120"/>
               </a:rPr>
-              <a:t>Relasi dengan pihak terdampak dipelihara atau tidak?</a:t>
+              <a:t>Sejauh mana relasi dengan pihak terdampak dipelihara?</a:t>
             </a:r>
             <a:endParaRPr lang="en-US" sz="1200" dirty="0"/>
           </a:p>
@@ -15203,7 +15161,7 @@
                 <a:ea typeface="Calibri" pitchFamily="34" charset="-122"/>
                 <a:cs typeface="Calibri" pitchFamily="34" charset="-120"/>
               </a:rPr>
-              <a:t>MENOLAK PROSES</a:t>
+              <a:t>MENOLAK PROSEDUR</a:t>
             </a:r>
             <a:endParaRPr lang="en-US" sz="900" dirty="0"/>
           </a:p>
@@ -15242,7 +15200,7 @@
                 <a:ea typeface="Cambria" pitchFamily="34" charset="-122"/>
                 <a:cs typeface="Cambria" pitchFamily="34" charset="-120"/>
               </a:rPr>
-              <a:t>Siapa yang hadir dan siapa yang absen?</a:t>
+              <a:t>Siapa yang hadir dan siapa yang absen dalam perumusan?</a:t>
             </a:r>
             <a:endParaRPr lang="en-US" sz="1200" dirty="0"/>
           </a:p>
@@ -15482,7 +15440,7 @@
                 <a:ea typeface="Calibri" pitchFamily="34" charset="-122"/>
                 <a:cs typeface="Calibri" pitchFamily="34" charset="-120"/>
               </a:rPr>
-              <a:t>ANTI ABSOLUT</a:t>
+              <a:t>RELATIVISTIK</a:t>
             </a:r>
             <a:endParaRPr lang="en-US" sz="900" dirty="0"/>
           </a:p>
@@ -15521,7 +15479,7 @@
                 <a:ea typeface="Cambria" pitchFamily="34" charset="-122"/>
                 <a:cs typeface="Cambria" pitchFamily="34" charset="-120"/>
               </a:rPr>
-              <a:t>Kepentingan siapa yang dilayani pilihan istilah?</a:t>
+              <a:t>Kepentingan siapa yang dilayani oleh pilihan istilah?</a:t>
             </a:r>
             <a:endParaRPr lang="en-US" sz="1200" dirty="0"/>
           </a:p>
@@ -15602,7 +15560,7 @@
                 <a:ea typeface="Calibri" pitchFamily="34" charset="-122"/>
                 <a:cs typeface="Calibri" pitchFamily="34" charset="-120"/>
               </a:rPr>
-              <a:t>Keempat lensa ini menyoroti apa yang luput dari lima lensa sebelumnya: pembanding, relasi, pihak yang absen, dan pilihan kata.</a:t>
+              <a:t>Keempat teori ini menyoroti dimensi yang luput dari lima teori sebelumnya: pembanding, relasi, keterwakilan, dan pilihan istilah.</a:t>
             </a:r>
             <a:endParaRPr lang="en-US" sz="900" dirty="0"/>
           </a:p>
@@ -15751,7 +15709,7 @@
                 <a:ea typeface="Cambria" pitchFamily="34" charset="-122"/>
                 <a:cs typeface="Cambria" pitchFamily="34" charset="-120"/>
               </a:rPr>
-              <a:t>Matriks putusan dan klaim nikel hijau</a:t>
+              <a:t>Sintesis penilaian dan evaluasi klaim</a:t>
             </a:r>
             <a:endParaRPr lang="en-US" sz="2800" dirty="0"/>
           </a:p>
@@ -15793,7 +15751,7 @@
                 <a:ea typeface="Calibri" pitchFamily="34" charset="-122"/>
                 <a:cs typeface="Calibri" pitchFamily="34" charset="-120"/>
               </a:rPr>
-              <a:t>Tidak satu pun dari sembilan lensa berbunyi mendukung tanpa syarat.</a:t>
+              <a:t>Tidak satu pun dari sembilan teori memberikan dukungan tanpa syarat.</a:t>
             </a:r>
             <a:endParaRPr lang="en-US" sz="1250" dirty="0"/>
           </a:p>
@@ -15859,7 +15817,7 @@
                 <a:ea typeface="Calibri" pitchFamily="34" charset="-122"/>
                 <a:cs typeface="Calibri" pitchFamily="34" charset="-120"/>
               </a:rPr>
-              <a:t>SEMBILAN PUTUSAN</a:t>
+              <a:t>SEMBILAN PENILAIAN</a:t>
             </a:r>
             <a:endParaRPr lang="en-US" sz="950" dirty="0"/>
           </a:p>
@@ -16147,7 +16105,7 @@
                 <a:ea typeface="Calibri" pitchFamily="34" charset="-122"/>
                 <a:cs typeface="Calibri" pitchFamily="34" charset="-120"/>
               </a:rPr>
-              <a:t>Terbelah</a:t>
+              <a:t>Ambivalen</a:t>
             </a:r>
             <a:endParaRPr lang="en-US" sz="1150" dirty="0"/>
           </a:p>
@@ -16723,7 +16681,7 @@
                 <a:ea typeface="Calibri" pitchFamily="34" charset="-122"/>
                 <a:cs typeface="Calibri" pitchFamily="34" charset="-120"/>
               </a:rPr>
-              <a:t>Menolak framing</a:t>
+              <a:t>Menolak pembanding</a:t>
             </a:r>
             <a:endParaRPr lang="en-US" sz="1150" dirty="0"/>
           </a:p>
@@ -17011,7 +16969,7 @@
                 <a:ea typeface="Calibri" pitchFamily="34" charset="-122"/>
                 <a:cs typeface="Calibri" pitchFamily="34" charset="-120"/>
               </a:rPr>
-              <a:t>Menolak proses</a:t>
+              <a:t>Menolak prosedur</a:t>
             </a:r>
             <a:endParaRPr lang="en-US" sz="1150" dirty="0"/>
           </a:p>
@@ -17155,7 +17113,7 @@
                 <a:ea typeface="Calibri" pitchFamily="34" charset="-122"/>
                 <a:cs typeface="Calibri" pitchFamily="34" charset="-120"/>
               </a:rPr>
-              <a:t>Anti absolut</a:t>
+              <a:t>Relativistik</a:t>
             </a:r>
             <a:endParaRPr lang="en-US" sz="1150" dirty="0"/>
           </a:p>
@@ -17221,7 +17179,7 @@
                 <a:ea typeface="Calibri" pitchFamily="34" charset="-122"/>
                 <a:cs typeface="Calibri" pitchFamily="34" charset="-120"/>
               </a:rPr>
-              <a:t>Enam menolak, satu bersyarat, satu terbelah, satu netral karena mengakui batas teorinya sendiri.</a:t>
+              <a:t>Enam menolak, satu bersyarat, satu ambivalen, dan satu netral karena mengakui keterbatasan teorinya sendiri.</a:t>
             </a:r>
             <a:endParaRPr lang="en-US" sz="1050" dirty="0"/>
           </a:p>
@@ -17260,7 +17218,7 @@
                 <a:ea typeface="Calibri" pitchFamily="34" charset="-122"/>
                 <a:cs typeface="Calibri" pitchFamily="34" charset="-120"/>
               </a:rPr>
-              <a:t>EMPAT PROPOSISI YANG DITURUNKAN DARI KESEMBILAN LENSA</a:t>
+              <a:t>EMPAT PROPOSISI YANG DITURUNKAN DARI KESEMBILAN TEORI</a:t>
             </a:r>
             <a:endParaRPr lang="en-US" sz="950" dirty="0"/>
           </a:p>
@@ -17434,7 +17392,7 @@
                 <a:ea typeface="Calibri" pitchFamily="34" charset="-122"/>
                 <a:cs typeface="Calibri" pitchFamily="34" charset="-120"/>
               </a:rPr>
-              <a:t>Keadaan yang lebih baik daripada ekspor bijih mentah tidak dengan sendirinya memadai. Virtue ethics menuntut pembanding pada standar tertinggi.</a:t>
+              <a:t>Kondisi yang lebih baik daripada ekspor bijih mentah tidak dengan sendirinya memadai. Virtue ethics menuntut pembanding pada standar tertinggi.</a:t>
             </a:r>
             <a:endParaRPr lang="en-US" sz="1100" dirty="0"/>
           </a:p>
@@ -18144,7 +18102,7 @@
                 <a:ea typeface="Cambria" pitchFamily="34" charset="-122"/>
                 <a:cs typeface="Cambria" pitchFamily="34" charset="-120"/>
               </a:rPr>
-              <a:t>Dua bagian, satu alur argumen</a:t>
+              <a:t>Sistematika pembahasan</a:t>
             </a:r>
             <a:endParaRPr lang="en-US" sz="2800" dirty="0"/>
           </a:p>
@@ -18186,7 +18144,7 @@
                 <a:ea typeface="Calibri" pitchFamily="34" charset="-122"/>
                 <a:cs typeface="Calibri" pitchFamily="34" charset="-120"/>
               </a:rPr>
-              <a:t>Teori dibangun lebih dahulu supaya kasusnya punya alat ukur, bukan sekadar punya opini.</a:t>
+              <a:t>Kerangka teoretis dibangun lebih dahulu agar analisis kasus memiliki dasar penilaian yang eksplisit.</a:t>
             </a:r>
             <a:endParaRPr lang="en-US" sz="1250" dirty="0"/>
           </a:p>
@@ -18201,11 +18159,11 @@
         <p:spPr>
           <a:xfrm>
             <a:off x="566928" y="1719072"/>
-            <a:ext cx="5321808" cy="3858768"/>
+            <a:ext cx="5321808" cy="4224528"/>
           </a:xfrm>
           <a:prstGeom prst="roundRect">
             <a:avLst>
-              <a:gd name="adj" fmla="val 2133"/>
+              <a:gd name="adj" fmla="val 1948"/>
             </a:avLst>
           </a:prstGeom>
           <a:solidFill>
@@ -18228,11 +18186,11 @@
         <p:spPr>
           <a:xfrm>
             <a:off x="6300216" y="1719072"/>
-            <a:ext cx="5321808" cy="3858768"/>
+            <a:ext cx="5321808" cy="4224528"/>
           </a:xfrm>
           <a:prstGeom prst="roundRect">
             <a:avLst>
-              <a:gd name="adj" fmla="val 2133"/>
+              <a:gd name="adj" fmla="val 1948"/>
             </a:avLst>
           </a:prstGeom>
           <a:solidFill>
@@ -18279,7 +18237,7 @@
                 <a:ea typeface="Calibri" pitchFamily="34" charset="-122"/>
                 <a:cs typeface="Calibri" pitchFamily="34" charset="-120"/>
               </a:rPr>
-              <a:t>BAGIAN SATU   |   TEORI   |   SLIDE 3 SAMPAI 14</a:t>
+              <a:t>BAGIAN SATU</a:t>
             </a:r>
             <a:endParaRPr lang="en-US" sz="950" dirty="0"/>
           </a:p>
@@ -18318,7 +18276,7 @@
                 <a:ea typeface="Calibri" pitchFamily="34" charset="-122"/>
                 <a:cs typeface="Calibri" pitchFamily="34" charset="-120"/>
               </a:rPr>
-              <a:t>BAGIAN DUA   |   KASUS   |   SLIDE 15 SAMPAI 20</a:t>
+              <a:t>BAGIAN DUA</a:t>
             </a:r>
             <a:endParaRPr lang="en-US" sz="950" dirty="0"/>
           </a:p>
@@ -18410,7 +18368,7 @@
         </p:nvSpPr>
         <p:spPr>
           <a:xfrm>
-            <a:off x="877824" y="2670048"/>
+            <a:off x="877824" y="2688336"/>
             <a:ext cx="402336" cy="274320"/>
           </a:xfrm>
           <a:prstGeom prst="rect">
@@ -18449,7 +18407,7 @@
         </p:nvSpPr>
         <p:spPr>
           <a:xfrm>
-            <a:off x="1316736" y="2670048"/>
+            <a:off x="1316736" y="2688336"/>
             <a:ext cx="4297680" cy="274320"/>
           </a:xfrm>
           <a:prstGeom prst="rect">
@@ -18488,7 +18446,7 @@
         </p:nvSpPr>
         <p:spPr>
           <a:xfrm>
-            <a:off x="877824" y="3118104"/>
+            <a:off x="877824" y="3200400"/>
             <a:ext cx="402336" cy="274320"/>
           </a:xfrm>
           <a:prstGeom prst="rect">
@@ -18527,7 +18485,7 @@
         </p:nvSpPr>
         <p:spPr>
           <a:xfrm>
-            <a:off x="1316736" y="3118104"/>
+            <a:off x="1316736" y="3200400"/>
             <a:ext cx="4297680" cy="274320"/>
           </a:xfrm>
           <a:prstGeom prst="rect">
@@ -18566,7 +18524,7 @@
         </p:nvSpPr>
         <p:spPr>
           <a:xfrm>
-            <a:off x="877824" y="3566160"/>
+            <a:off x="877824" y="3712464"/>
             <a:ext cx="402336" cy="274320"/>
           </a:xfrm>
           <a:prstGeom prst="rect">
@@ -18605,7 +18563,7 @@
         </p:nvSpPr>
         <p:spPr>
           <a:xfrm>
-            <a:off x="1316736" y="3566160"/>
+            <a:off x="1316736" y="3712464"/>
             <a:ext cx="4297680" cy="274320"/>
           </a:xfrm>
           <a:prstGeom prst="rect">
@@ -18630,7 +18588,7 @@
                 <a:ea typeface="Calibri" pitchFamily="34" charset="-122"/>
                 <a:cs typeface="Calibri" pitchFamily="34" charset="-120"/>
               </a:rPr>
-              <a:t>Peta sembilan teori</a:t>
+              <a:t>Klasifikasi sembilan teori</a:t>
             </a:r>
             <a:endParaRPr lang="en-US" sz="1250" dirty="0"/>
           </a:p>
@@ -18644,7 +18602,7 @@
         </p:nvSpPr>
         <p:spPr>
           <a:xfrm>
-            <a:off x="877824" y="4014216"/>
+            <a:off x="877824" y="4224528"/>
             <a:ext cx="402336" cy="274320"/>
           </a:xfrm>
           <a:prstGeom prst="rect">
@@ -18683,7 +18641,7 @@
         </p:nvSpPr>
         <p:spPr>
           <a:xfrm>
-            <a:off x="1316736" y="4014216"/>
+            <a:off x="1316736" y="4224528"/>
             <a:ext cx="4297680" cy="274320"/>
           </a:xfrm>
           <a:prstGeom prst="rect">
@@ -18722,7 +18680,7 @@
         </p:nvSpPr>
         <p:spPr>
           <a:xfrm>
-            <a:off x="877824" y="4462272"/>
+            <a:off x="877824" y="4736592"/>
             <a:ext cx="402336" cy="274320"/>
           </a:xfrm>
           <a:prstGeom prst="rect">
@@ -18761,7 +18719,7 @@
         </p:nvSpPr>
         <p:spPr>
           <a:xfrm>
-            <a:off x="1316736" y="4462272"/>
+            <a:off x="1316736" y="4736592"/>
             <a:ext cx="4297680" cy="274320"/>
           </a:xfrm>
           <a:prstGeom prst="rect">
@@ -18786,7 +18744,7 @@
                 <a:ea typeface="Calibri" pitchFamily="34" charset="-122"/>
                 <a:cs typeface="Calibri" pitchFamily="34" charset="-120"/>
               </a:rPr>
-              <a:t>Batas teori modernis Barat</a:t>
+              <a:t>Keterbatasan teori modernis</a:t>
             </a:r>
             <a:endParaRPr lang="en-US" sz="1250" dirty="0"/>
           </a:p>
@@ -18800,7 +18758,7 @@
         </p:nvSpPr>
         <p:spPr>
           <a:xfrm>
-            <a:off x="877824" y="4910328"/>
+            <a:off x="877824" y="5248656"/>
             <a:ext cx="402336" cy="274320"/>
           </a:xfrm>
           <a:prstGeom prst="rect">
@@ -18839,7 +18797,7 @@
         </p:nvSpPr>
         <p:spPr>
           <a:xfrm>
-            <a:off x="1316736" y="4910328"/>
+            <a:off x="1316736" y="5248656"/>
             <a:ext cx="4297680" cy="274320"/>
           </a:xfrm>
           <a:prstGeom prst="rect">
@@ -18878,7 +18836,7 @@
         </p:nvSpPr>
         <p:spPr>
           <a:xfrm>
-            <a:off x="6611112" y="2670048"/>
+            <a:off x="6611112" y="2688336"/>
             <a:ext cx="402336" cy="274320"/>
           </a:xfrm>
           <a:prstGeom prst="rect">
@@ -18917,7 +18875,7 @@
         </p:nvSpPr>
         <p:spPr>
           <a:xfrm>
-            <a:off x="7050024" y="2670048"/>
+            <a:off x="7050024" y="2688336"/>
             <a:ext cx="4297680" cy="274320"/>
           </a:xfrm>
           <a:prstGeom prst="rect">
@@ -18956,7 +18914,7 @@
         </p:nvSpPr>
         <p:spPr>
           <a:xfrm>
-            <a:off x="6611112" y="3118104"/>
+            <a:off x="6611112" y="3200400"/>
             <a:ext cx="402336" cy="274320"/>
           </a:xfrm>
           <a:prstGeom prst="rect">
@@ -18995,7 +18953,7 @@
         </p:nvSpPr>
         <p:spPr>
           <a:xfrm>
-            <a:off x="7050024" y="3118104"/>
+            <a:off x="7050024" y="3200400"/>
             <a:ext cx="4297680" cy="274320"/>
           </a:xfrm>
           <a:prstGeom prst="rect">
@@ -19034,7 +18992,7 @@
         </p:nvSpPr>
         <p:spPr>
           <a:xfrm>
-            <a:off x="6611112" y="3566160"/>
+            <a:off x="6611112" y="3712464"/>
             <a:ext cx="402336" cy="274320"/>
           </a:xfrm>
           <a:prstGeom prst="rect">
@@ -19073,7 +19031,7 @@
         </p:nvSpPr>
         <p:spPr>
           <a:xfrm>
-            <a:off x="7050024" y="3566160"/>
+            <a:off x="7050024" y="3712464"/>
             <a:ext cx="4297680" cy="274320"/>
           </a:xfrm>
           <a:prstGeom prst="rect">
@@ -19098,7 +19056,7 @@
                 <a:ea typeface="Calibri" pitchFamily="34" charset="-122"/>
                 <a:cs typeface="Calibri" pitchFamily="34" charset="-120"/>
               </a:rPr>
-              <a:t>Uji lima lensa modernis</a:t>
+              <a:t>Penilaian lima teori modernis</a:t>
             </a:r>
             <a:endParaRPr lang="en-US" sz="1250" dirty="0"/>
           </a:p>
@@ -19112,7 +19070,7 @@
         </p:nvSpPr>
         <p:spPr>
           <a:xfrm>
-            <a:off x="6611112" y="4014216"/>
+            <a:off x="6611112" y="4224528"/>
             <a:ext cx="402336" cy="274320"/>
           </a:xfrm>
           <a:prstGeom prst="rect">
@@ -19151,7 +19109,7 @@
         </p:nvSpPr>
         <p:spPr>
           <a:xfrm>
-            <a:off x="7050024" y="4014216"/>
+            <a:off x="7050024" y="4224528"/>
             <a:ext cx="4297680" cy="274320"/>
           </a:xfrm>
           <a:prstGeom prst="rect">
@@ -19176,7 +19134,7 @@
                 <a:ea typeface="Calibri" pitchFamily="34" charset="-122"/>
                 <a:cs typeface="Calibri" pitchFamily="34" charset="-120"/>
               </a:rPr>
-              <a:t>Uji empat lensa alternatif</a:t>
+              <a:t>Penilaian empat teori alternatif</a:t>
             </a:r>
             <a:endParaRPr lang="en-US" sz="1250" dirty="0"/>
           </a:p>
@@ -19190,7 +19148,7 @@
         </p:nvSpPr>
         <p:spPr>
           <a:xfrm>
-            <a:off x="6611112" y="4462272"/>
+            <a:off x="6611112" y="4736592"/>
             <a:ext cx="402336" cy="274320"/>
           </a:xfrm>
           <a:prstGeom prst="rect">
@@ -19229,7 +19187,7 @@
         </p:nvSpPr>
         <p:spPr>
           <a:xfrm>
-            <a:off x="7050024" y="4462272"/>
+            <a:off x="7050024" y="4736592"/>
             <a:ext cx="4297680" cy="274320"/>
           </a:xfrm>
           <a:prstGeom prst="rect">
@@ -19254,7 +19212,7 @@
                 <a:ea typeface="Calibri" pitchFamily="34" charset="-122"/>
                 <a:cs typeface="Calibri" pitchFamily="34" charset="-120"/>
               </a:rPr>
-              <a:t>Matriks putusan dan klaim nikel hijau</a:t>
+              <a:t>Sintesis penilaian dan evaluasi klaim</a:t>
             </a:r>
             <a:endParaRPr lang="en-US" sz="1250" dirty="0"/>
           </a:p>
@@ -19268,7 +19226,7 @@
         </p:nvSpPr>
         <p:spPr>
           <a:xfrm>
-            <a:off x="6611112" y="4910328"/>
+            <a:off x="6611112" y="5248656"/>
             <a:ext cx="402336" cy="274320"/>
           </a:xfrm>
           <a:prstGeom prst="rect">
@@ -19307,7 +19265,7 @@
         </p:nvSpPr>
         <p:spPr>
           <a:xfrm>
-            <a:off x="7050024" y="4910328"/>
+            <a:off x="7050024" y="5248656"/>
             <a:ext cx="4297680" cy="274320"/>
           </a:xfrm>
           <a:prstGeom prst="rect">
@@ -19340,73 +19298,7 @@
       </p:sp>
       <p:sp>
         <p:nvSpPr>
-          <p:cNvPr id="35" name="Shape 33"/>
-          <p:cNvSpPr/>
-          <p:nvPr/>
-        </p:nvSpPr>
-        <p:spPr>
-          <a:xfrm>
-            <a:off x="566928" y="5779008"/>
-            <a:ext cx="11057839" cy="484632"/>
-          </a:xfrm>
-          <a:prstGeom prst="roundRect">
-            <a:avLst>
-              <a:gd name="adj" fmla="val 16981"/>
-            </a:avLst>
-          </a:prstGeom>
-          <a:solidFill>
-            <a:srgbClr val="F6EAE3"/>
-          </a:solidFill>
-          <a:ln w="12700">
-            <a:solidFill>
-              <a:srgbClr val="F6EAE3"/>
-            </a:solidFill>
-            <a:prstDash val="solid"/>
-          </a:ln>
-        </p:spPr>
-      </p:sp>
-      <p:sp>
-        <p:nvSpPr>
-          <p:cNvPr id="36" name="Text 34"/>
-          <p:cNvSpPr txBox="1"/>
-          <p:nvPr/>
-        </p:nvSpPr>
-        <p:spPr>
-          <a:xfrm>
-            <a:off x="877824" y="5779008"/>
-            <a:ext cx="10436047" cy="484632"/>
-          </a:xfrm>
-          <a:prstGeom prst="rect">
-            <a:avLst/>
-          </a:prstGeom>
-          <a:noFill/>
-          <a:ln/>
-        </p:spPr>
-        <p:txBody>
-          <a:bodyPr wrap="square" lIns="0" tIns="0" rIns="0" bIns="0" rtlCol="0" anchor="ctr"/>
-          <a:lstStyle/>
-          <a:p>
-            <a:pPr indent="0" marL="0">
-              <a:buNone/>
-            </a:pPr>
-            <a:r>
-              <a:rPr lang="en-US" sz="1200" i="1" dirty="0">
-                <a:solidFill>
-                  <a:srgbClr val="7A3A1C"/>
-                </a:solidFill>
-                <a:latin typeface="Calibri" pitchFamily="34" charset="0"/>
-                <a:ea typeface="Calibri" pitchFamily="34" charset="-122"/>
-                <a:cs typeface="Calibri" pitchFamily="34" charset="-120"/>
-              </a:rPr>
-              <a:t>Satu pesan yang dibawa sepanjang presentasi: sengketa etis pada kasus ini bukan sengketa fakta, melainkan sengketa kriteria penilaian.</a:t>
-            </a:r>
-            <a:endParaRPr lang="en-US" sz="1200" dirty="0"/>
-          </a:p>
-        </p:txBody>
-      </p:sp>
-      <p:sp>
-        <p:nvSpPr>
-          <p:cNvPr id="37" name="Text 35"/>
+          <p:cNvPr id="35" name="Text 33"/>
           <p:cNvSpPr txBox="1"/>
           <p:nvPr/>
         </p:nvSpPr>
@@ -19589,7 +19481,7 @@
                 <a:ea typeface="Calibri" pitchFamily="34" charset="-122"/>
                 <a:cs typeface="Calibri" pitchFamily="34" charset="-120"/>
               </a:rPr>
-              <a:t>Tiga temuan dari pengujian, lalu tiga tindak lanjut yang bisa langsung dikerjakan manajemen.</a:t>
+              <a:t>Tiga temuan dari pengujian, diikuti tiga tindak lanjut yang dapat dijalankan manajemen.</a:t>
             </a:r>
             <a:endParaRPr lang="en-US" sz="1250" dirty="0"/>
           </a:p>
@@ -19901,7 +19793,7 @@
                 <a:ea typeface="Cambria" pitchFamily="34" charset="-122"/>
                 <a:cs typeface="Cambria" pitchFamily="34" charset="-120"/>
               </a:rPr>
-              <a:t>Yang gugur adalah klaimnya</a:t>
+              <a:t>Klaim etis yang gugur</a:t>
             </a:r>
             <a:endParaRPr lang="en-US" sz="1550" dirty="0"/>
           </a:p>
@@ -20078,7 +19970,7 @@
                 <a:ea typeface="Cambria" pitchFamily="34" charset="-122"/>
                 <a:cs typeface="Cambria" pitchFamily="34" charset="-120"/>
               </a:rPr>
-              <a:t>Kasusnya belum selesai</a:t>
+              <a:t>Kasus yang masih berlangsung</a:t>
             </a:r>
             <a:endParaRPr lang="en-US" sz="1550" dirty="0"/>
           </a:p>
@@ -20333,7 +20225,7 @@
                 <a:ea typeface="Cambria" pitchFamily="34" charset="-122"/>
                 <a:cs typeface="Cambria" pitchFamily="34" charset="-120"/>
               </a:rPr>
-              <a:t>Hadirkan pihak yang absen</a:t>
+              <a:t>Pelibatan pihak yang absen</a:t>
             </a:r>
             <a:endParaRPr lang="en-US" sz="1350" dirty="0"/>
           </a:p>
@@ -20441,7 +20333,7 @@
                 <a:ea typeface="Cambria" pitchFamily="34" charset="-122"/>
                 <a:cs typeface="Cambria" pitchFamily="34" charset="-120"/>
               </a:rPr>
-              <a:t>Uji dengan banyak teori</a:t>
+              <a:t>Pengujian multiteori</a:t>
             </a:r>
             <a:endParaRPr lang="en-US" sz="1350" dirty="0"/>
           </a:p>
@@ -20483,7 +20375,7 @@
                 <a:ea typeface="Calibri" pitchFamily="34" charset="-122"/>
                 <a:cs typeface="Calibri" pitchFamily="34" charset="-120"/>
               </a:rPr>
-              <a:t>Klaim yang lolos utilitarianism kerap gugur pada keadilan distributif dan discourse ethics. Sembilan pertimbangan tadi jadi daftar periksa.</a:t>
+              <a:t>Klaim yang lolos utilitarianism kerap gugur pada keadilan distributif dan discourse ethics. Kesembilan teori berfungsi sebagai daftar periksa.</a:t>
             </a:r>
             <a:endParaRPr lang="en-US" sz="1100" dirty="0"/>
           </a:p>
@@ -20740,7 +20632,7 @@
                 <a:ea typeface="Calibri" pitchFamily="34" charset="-122"/>
                 <a:cs typeface="Calibri" pitchFamily="34" charset="-120"/>
               </a:rPr>
-              <a:t>Di ruang pribadi kita cukup mengandalkan intuisi. Di dunia bisnis, penilaian harus bisa dipertahankan di hadapan pemangku kepentingan.</a:t>
+              <a:t>Dalam ranah personal intuisi memadai. Dalam konteks bisnis, penilaian etis harus dapat dipertahankan di hadapan pemangku kepentingan.</a:t>
             </a:r>
             <a:endParaRPr lang="en-US" sz="1250" dirty="0"/>
           </a:p>
@@ -20806,7 +20698,7 @@
                 <a:ea typeface="Calibri" pitchFamily="34" charset="-122"/>
                 <a:cs typeface="Calibri" pitchFamily="34" charset="-120"/>
               </a:rPr>
-              <a:t>DEFINISI BUKU</a:t>
+              <a:t>DEFINISI KONSEP</a:t>
             </a:r>
             <a:endParaRPr lang="en-US" sz="950" dirty="0"/>
           </a:p>
@@ -21127,7 +21019,7 @@
                 <a:ea typeface="Cambria" pitchFamily="34" charset="-122"/>
                 <a:cs typeface="Cambria" pitchFamily="34" charset="-120"/>
               </a:rPr>
-              <a:t>Merapikan intuisi</a:t>
+              <a:t>Rasionalisasi intuisi moral</a:t>
             </a:r>
             <a:endParaRPr lang="en-US" sz="1450" dirty="0"/>
           </a:p>
@@ -21169,7 +21061,7 @@
                 <a:ea typeface="Calibri" pitchFamily="34" charset="-122"/>
                 <a:cs typeface="Calibri" pitchFamily="34" charset="-120"/>
               </a:rPr>
-              <a:t>Nilai utama teori etika terletak pada kemampuannya merasionalkan, menjelaskan, dan memahami firasat moral yang sudah kita punya soal benar dan salah.</a:t>
+              <a:t>Teori etika berfungsi merasionalkan, menjelaskan, dan memahami intuisi moral yang telah dimiliki mengenai benar dan salah.</a:t>
             </a:r>
             <a:endParaRPr lang="en-US" sz="1150" dirty="0"/>
           </a:p>
@@ -21301,7 +21193,7 @@
                 <a:ea typeface="Cambria" pitchFamily="34" charset="-122"/>
                 <a:cs typeface="Cambria" pitchFamily="34" charset="-120"/>
               </a:rPr>
-              <a:t>Membuka percakapan</a:t>
+              <a:t>Dasar diskusi rasional</a:t>
             </a:r>
             <a:endParaRPr lang="en-US" sz="1450" dirty="0"/>
           </a:p>
@@ -21343,7 +21235,7 @@
                 <a:ea typeface="Calibri" pitchFamily="34" charset="-122"/>
                 <a:cs typeface="Calibri" pitchFamily="34" charset="-120"/>
               </a:rPr>
-              <a:t>Teori memungkinkan diskusi rasional antara orang yang nilai moralnya berbeda, sehingga perbedaan tidak berhenti sebagai selera.</a:t>
+              <a:t>Teori memungkinkan diskursus rasional antarpihak yang berbeda nilai moral, sehingga perbedaan tidak berhenti pada tataran preferensi.</a:t>
             </a:r>
             <a:endParaRPr lang="en-US" sz="1150" dirty="0"/>
           </a:p>
@@ -21475,7 +21367,7 @@
                 <a:ea typeface="Cambria" pitchFamily="34" charset="-122"/>
                 <a:cs typeface="Cambria" pitchFamily="34" charset="-120"/>
               </a:rPr>
-              <a:t>Menopang keputusan</a:t>
+              <a:t>Justifikasi keputusan bisnis</a:t>
             </a:r>
             <a:endParaRPr lang="en-US" sz="1450" dirty="0"/>
           </a:p>
@@ -21517,7 +21409,7 @@
                 <a:ea typeface="Calibri" pitchFamily="34" charset="-122"/>
                 <a:cs typeface="Calibri" pitchFamily="34" charset="-120"/>
               </a:rPr>
-              <a:t>Keputusan bisnis perlu alasan sistematis dan argumen yang bisa dipahami umum, supaya dapat dibela, dibenarkan, dan dijelaskan kepada pemangku kepentingan.</a:t>
+              <a:t>Keputusan bisnis menuntut dasar rasional yang sistematis dan dapat dipertanggungjawabkan kepada pemangku kepentingan.</a:t>
             </a:r>
             <a:endParaRPr lang="en-US" sz="1150" dirty="0"/>
           </a:p>
@@ -21747,7 +21639,7 @@
                 <a:ea typeface="Calibri" pitchFamily="34" charset="-122"/>
                 <a:cs typeface="Calibri" pitchFamily="34" charset="-120"/>
               </a:rPr>
-              <a:t>Sebelum memakai teori, kita perlu tahu seberapa jauh satu teori mengklaim dirinya berlaku.</a:t>
+              <a:t>Sebelum menerapkan teori, perlu ditetapkan seberapa luas klaim keberlakuan yang diajukan teori tersebut.</a:t>
             </a:r>
             <a:endParaRPr lang="en-US" sz="1250" dirty="0"/>
           </a:p>
@@ -21926,7 +21818,7 @@
                 <a:ea typeface="Calibri" pitchFamily="34" charset="-122"/>
                 <a:cs typeface="Calibri" pitchFamily="34" charset="-120"/>
               </a:rPr>
-              <a:t>Hampir semua teori modernis Barat berdiri di sini. Kekuatannya jelas: ia memberi jawaban yang tegas.</a:t>
+              <a:t>Hampir seluruh teori modernis Barat berada pada posisi ini. Keunggulannya terletak pada ketegasan kesimpulan yang dihasilkan.</a:t>
             </a:r>
             <a:endParaRPr lang="en-US" sz="1150" dirty="0"/>
           </a:p>
@@ -22213,7 +22105,7 @@
                 <a:ea typeface="Cambria" pitchFamily="34" charset="-122"/>
                 <a:cs typeface="Cambria" pitchFamily="34" charset="-120"/>
               </a:rPr>
-              <a:t>Posisi yang diambil Crane dan Matten</a:t>
+              <a:t>Nilai yang bertentangan dapat sama sahnya</a:t>
             </a:r>
             <a:endParaRPr lang="en-US" sz="1500" dirty="0"/>
           </a:p>
@@ -22255,7 +22147,7 @@
                 <a:ea typeface="Calibri" pitchFamily="34" charset="-122"/>
                 <a:cs typeface="Calibri" pitchFamily="34" charset="-120"/>
               </a:rPr>
-              <a:t>Nilai yang saling bertentangan bisa sama sahnya dan perlu ditoleransi. Pluralisme tidak menyamaratakan semua perspektif, tetapi juga tidak mengunggulkan satu di atas yang lain.</a:t>
+              <a:t>Posisi yang diambil Crane dan Matten. Pluralisme tidak menyamaratakan seluruh perspektif, tetapi juga tidak mengunggulkan satu perspektif di atas yang lain.</a:t>
             </a:r>
             <a:endParaRPr lang="en-US" sz="1150" dirty="0"/>
           </a:p>
@@ -22284,7 +22176,7 @@
                 <a:ea typeface="Calibri" pitchFamily="34" charset="-122"/>
                 <a:cs typeface="Calibri" pitchFamily="34" charset="-120"/>
               </a:rPr>
-              <a:t>Konflik antar teori bukan kegagalan, melainkan bagian yang harus dikelola.</a:t>
+              <a:t>Konflik antarteori bukan kegagalan, melainkan konsekuensi yang harus dikelola.</a:t>
             </a:r>
             <a:endParaRPr lang="en-US" sz="1150" dirty="0"/>
           </a:p>
@@ -22353,7 +22245,7 @@
                 <a:ea typeface="Calibri" pitchFamily="34" charset="-122"/>
                 <a:cs typeface="Calibri" pitchFamily="34" charset="-120"/>
               </a:rPr>
-              <a:t>Dua rambu dari buku.   </a:t>
+              <a:t>Catatan kritis.   </a:t>
             </a:r>
             <a:pPr indent="0" marL="0">
               <a:lnSpc>
@@ -22370,7 +22262,7 @@
                 <a:ea typeface="Calibri" pitchFamily="34" charset="-122"/>
                 <a:cs typeface="Calibri" pitchFamily="34" charset="-120"/>
               </a:rPr>
-              <a:t>Amartya Sen (2000) menilai pluralisme membuka kepekaan pada kenyataan baru, sesuatu yang tidak diberikan satu teori umum. Sebaliknya Irene Liu (2018) mengingatkan bahwa pluralisme berisiko terlalu toleran, karena sebagian praktik dan tradisi memang keliru dan tidak layak ditoleransi.</a:t>
+              <a:t>Sen (2000) menilai pluralisme membuka kepekaan terhadap realitas yang berubah, sesuatu yang tidak disediakan oleh teori tunggal. Liu (2018) sebaliknya mengingatkan risiko toleransi berlebih, sebab sebagian praktik dan tradisi memang tidak layak ditoleransi.</a:t>
             </a:r>
             <a:endParaRPr lang="en-US" sz="1200" dirty="0"/>
           </a:p>
@@ -22519,7 +22411,7 @@
                 <a:ea typeface="Calibri" pitchFamily="34" charset="-122"/>
                 <a:cs typeface="Calibri" pitchFamily="34" charset="-120"/>
               </a:rPr>
-              <a:t>03   PETA TEORI</a:t>
+              <a:t>03   KLASIFIKASI TEORI</a:t>
             </a:r>
             <a:endParaRPr lang="en-US" sz="1000" dirty="0"/>
           </a:p>
@@ -22558,7 +22450,7 @@
                 <a:ea typeface="Cambria" pitchFamily="34" charset="-122"/>
                 <a:cs typeface="Cambria" pitchFamily="34" charset="-120"/>
               </a:rPr>
-              <a:t>Sembilan teori dalam dua keluarga besar</a:t>
+              <a:t>Klasifikasi sembilan teori etika normatif</a:t>
             </a:r>
             <a:endParaRPr lang="en-US" sz="2800" dirty="0"/>
           </a:p>
@@ -22600,7 +22492,7 @@
                 <a:ea typeface="Calibri" pitchFamily="34" charset="-122"/>
                 <a:cs typeface="Calibri" pitchFamily="34" charset="-120"/>
               </a:rPr>
-              <a:t>Keluarga pertama menilai tindakan. Keluarga kedua menilai pelaku, relasi, prosedur, dan bahasa.</a:t>
+              <a:t>Klasifikasi pertama menilai tindakan. Klasifikasi kedua menilai pelaku, relasi, prosedur, dan bahasa.</a:t>
             </a:r>
             <a:endParaRPr lang="en-US" sz="1250" dirty="0"/>
           </a:p>
@@ -22666,7 +22558,7 @@
                 <a:ea typeface="Calibri" pitchFamily="34" charset="-122"/>
                 <a:cs typeface="Calibri" pitchFamily="34" charset="-120"/>
               </a:rPr>
-              <a:t>KELUARGA SATU   |   TEORI MODERNIS BARAT</a:t>
+              <a:t>KLASIFIKASI I   |   TEORI MODERNIS BARAT</a:t>
             </a:r>
             <a:endParaRPr lang="en-US" sz="950" dirty="0"/>
           </a:p>
@@ -22708,7 +22600,7 @@
                 <a:ea typeface="Calibri" pitchFamily="34" charset="-122"/>
                 <a:cs typeface="Calibri" pitchFamily="34" charset="-120"/>
               </a:rPr>
-              <a:t>Berakar pada Pencerahan abad ke-18, bersifat absolutis, dan menawarkan aturan yang bisa diterapkan pada situasi apa pun. Keunggulannya: memberi solusi yang tidak mendua.</a:t>
+              <a:t>Berakar pada Pencerahan abad ke-18, bersifat absolutis, dan menawarkan aturan yang dapat diterapkan pada situasi apa pun. Keunggulannya terletak pada solusi yang tidak mendua.</a:t>
             </a:r>
             <a:endParaRPr lang="en-US" sz="1150" dirty="0"/>
           </a:p>
@@ -23485,7 +23377,7 @@
                 <a:ea typeface="Calibri" pitchFamily="34" charset="-122"/>
                 <a:cs typeface="Calibri" pitchFamily="34" charset="-120"/>
               </a:rPr>
-              <a:t>Semua teori ini normatif karena berangkat dari asumsi tentang hakikat dunia dan hakikat manusia. Sejauh mana kita bisa menerima kesimpulannya bergantung pada sejauh mana kita berbagi asumsi itu.</a:t>
+              <a:t>Seluruh teori ini bersifat normatif karena berangkat dari asumsi tentang hakikat dunia dan hakikat manusia. Penerimaan atas kesimpulannya bergantung pada penerimaan atas asumsi tersebut.</a:t>
             </a:r>
             <a:endParaRPr lang="en-US" sz="1150" dirty="0"/>
           </a:p>
@@ -23551,7 +23443,7 @@
                 <a:ea typeface="Calibri" pitchFamily="34" charset="-122"/>
                 <a:cs typeface="Calibri" pitchFamily="34" charset="-120"/>
               </a:rPr>
-              <a:t>KELUARGA DUA   |   ALTERNATIF</a:t>
+              <a:t>KLASIFIKASI II   |   TEORI ALTERNATIF</a:t>
             </a:r>
             <a:endParaRPr lang="en-US" sz="950" dirty="0"/>
           </a:p>
@@ -23632,7 +23524,7 @@
                 <a:ea typeface="Calibri" pitchFamily="34" charset="-122"/>
                 <a:cs typeface="Calibri" pitchFamily="34" charset="-120"/>
               </a:rPr>
-              <a:t>Cenderung relativis. Lahir dari keberatan atas keluarga pertama, dan menyoroti dimensi yang tidak tertangkap aturan universal.</a:t>
+              <a:t>Cenderung relativis. Lahir dari keberatan atas klasifikasi pertama, dan menyoroti dimensi yang tidak tertangkap oleh aturan universal.</a:t>
             </a:r>
             <a:endParaRPr lang="en-US" sz="1150" dirty="0"/>
           </a:p>
@@ -24438,7 +24330,7 @@
                 <a:ea typeface="Calibri" pitchFamily="34" charset="-122"/>
                 <a:cs typeface="Calibri" pitchFamily="34" charset="-120"/>
               </a:rPr>
-              <a:t>Teori tertua sekaligus paling diperdebatkan. Sebagian penulis bahkan menolak memasukkannya sebagai teori moral.</a:t>
+              <a:t>Teori tertua sekaligus paling diperdebatkan. Sebagian penulis bahkan menolak mengategorikannya sebagai teori moral.</a:t>
             </a:r>
             <a:endParaRPr lang="en-US" sz="1250" dirty="0"/>
           </a:p>
@@ -24678,7 +24570,7 @@
                 <a:ea typeface="Calibri" pitchFamily="34" charset="-122"/>
                 <a:cs typeface="Calibri" pitchFamily="34" charset="-120"/>
               </a:rPr>
-              <a:t>PEMBEDAAN YANG MENENTUKAN</a:t>
+              <a:t>PEMBEDAAN KONSEPTUAL</a:t>
             </a:r>
             <a:endParaRPr lang="en-US" sz="950" dirty="0"/>
           </a:p>
@@ -24720,7 +24612,7 @@
                 <a:ea typeface="Calibri" pitchFamily="34" charset="-122"/>
                 <a:cs typeface="Calibri" pitchFamily="34" charset="-120"/>
               </a:rPr>
-              <a:t>Egoisme tidak sama dengan keserakahan. Orang egois masih bisa tergerak oleh rasa iba, sedangkan orang serakah tidak peka pada yang lain.</a:t>
+              <a:t>Egoisme berbeda dari keserakahan. Pelaku egois masih dapat tergerak oleh rasa iba, sedangkan pelaku serakah tidak peka pada kepentingan pihak lain.</a:t>
             </a:r>
             <a:endParaRPr lang="en-US" sz="1150" dirty="0"/>
           </a:p>
@@ -24749,7 +24641,7 @@
                 <a:ea typeface="Calibri" pitchFamily="34" charset="-122"/>
                 <a:cs typeface="Calibri" pitchFamily="34" charset="-120"/>
               </a:rPr>
-              <a:t>Egoisme berbasis kepentingan jangka panjang lebih kuat daripada egoisme berbasis keinginan, karena hanya yang pertama bisa membedakan mahasiswa yang mabuk setiap malam dari mahasiswa yang belajar keras.</a:t>
+              <a:t>Egoisme berbasis kepentingan jangka panjang lebih kuat daripada egoisme berbasis keinginan, sebab hanya yang pertama mampu membedakan kualitas pilihan hidup seseorang.</a:t>
             </a:r>
             <a:endParaRPr lang="en-US" sz="1150" dirty="0"/>
           </a:p>
@@ -24815,7 +24707,7 @@
                 <a:ea typeface="Cambria" pitchFamily="34" charset="-122"/>
                 <a:cs typeface="Cambria" pitchFamily="34" charset="-120"/>
               </a:rPr>
-              <a:t>Tokoh dan karya</a:t>
+              <a:t>Tokoh dan karya utama</a:t>
             </a:r>
             <a:endParaRPr lang="en-US" sz="1450" dirty="0"/>
           </a:p>
@@ -24965,7 +24857,7 @@
                 <a:ea typeface="Calibri" pitchFamily="34" charset="-122"/>
                 <a:cs typeface="Calibri" pitchFamily="34" charset="-120"/>
               </a:rPr>
-              <a:t>Perusahaan menyokong sekolah atau layanan kesehatan setempat bukan karena altruisme, melainkan karena lingkungan sosial yang membaik menguntungkan retensi tenaga kerjanya.</a:t>
+              <a:t>Perusahaan menyokong sekolah atau layanan kesehatan setempat bukan atas dasar altruisme, melainkan karena perbaikan lingkungan sosial menguntungkan retensi tenaga kerjanya.</a:t>
             </a:r>
             <a:endParaRPr lang="en-US" sz="1150" dirty="0"/>
           </a:p>
@@ -25031,7 +24923,7 @@
                 <a:ea typeface="Cambria" pitchFamily="34" charset="-122"/>
                 <a:cs typeface="Cambria" pitchFamily="34" charset="-120"/>
               </a:rPr>
-              <a:t>Batas teorinya</a:t>
+              <a:t>Keterbatasan teori</a:t>
             </a:r>
             <a:endParaRPr lang="en-US" sz="1450" dirty="0"/>
           </a:p>
@@ -25073,7 +24965,7 @@
                 <a:ea typeface="Calibri" pitchFamily="34" charset="-122"/>
                 <a:cs typeface="Calibri" pitchFamily="34" charset="-120"/>
               </a:rPr>
-              <a:t>Teori ini hanya bekerja bila pasar mencegah satu egois merugikan egois lain. Ia gugur pada kegagalan pasar dan pada isu keberlanjutan, karena korban penipisan sumber daya adalah generasi yang belum hadir.</a:t>
+              <a:t>Teori ini hanya berlaku bila pasar mencegah satu pelaku egois merugikan pelaku lain. Ia gugur pada kegagalan pasar dan pada isu keberlanjutan, sebab korban penipisan sumber daya adalah generasi mendatang.</a:t>
             </a:r>
             <a:endParaRPr lang="en-US" sz="1150" dirty="0"/>
           </a:p>
@@ -25303,7 +25195,7 @@
                 <a:ea typeface="Calibri" pitchFamily="34" charset="-122"/>
                 <a:cs typeface="Calibri" pitchFamily="34" charset="-120"/>
               </a:rPr>
-              <a:t>Teori paling lazim dipakai di dunia bisnis, karena paling dekat dengan cara ekonomi berpikir.</a:t>
+              <a:t>Teori yang paling lazim diterapkan dalam bisnis karena kompatibel dengan metodologi kuantitatif ekonomi.</a:t>
             </a:r>
             <a:endParaRPr lang="en-US" sz="1250" dirty="0"/>
           </a:p>
@@ -25585,7 +25477,7 @@
                 <a:ea typeface="Calibri" pitchFamily="34" charset="-122"/>
                 <a:cs typeface="Calibri" pitchFamily="34" charset="-120"/>
               </a:rPr>
-              <a:t>Yang dinilai akibatnya</a:t>
+              <a:t>Objek penilaiannya akibat</a:t>
             </a:r>
             <a:endParaRPr lang="en-US" sz="1050" dirty="0"/>
           </a:p>
@@ -26191,7 +26083,7 @@
                 <a:ea typeface="Calibri" pitchFamily="34" charset="-122"/>
                 <a:cs typeface="Calibri" pitchFamily="34" charset="-120"/>
               </a:rPr>
-              <a:t>EMPAT MASALAH KLASIK</a:t>
+              <a:t>EMPAT KEBERATAN UTAMA</a:t>
             </a:r>
             <a:endParaRPr lang="en-US" sz="950" dirty="0"/>
           </a:p>
@@ -26272,7 +26164,7 @@
                 <a:ea typeface="Calibri" pitchFamily="34" charset="-122"/>
                 <a:cs typeface="Calibri" pitchFamily="34" charset="-120"/>
               </a:rPr>
-              <a:t>Penilaian pleasure dan pain bergantung pada siapa yang menghitung, dan siapa yang layak masuk hitungan.</a:t>
+              <a:t>Penilaian pleasure dan pain bergantung pada pihak yang menghitung dan pada cakupan yang diperhitungkan.</a:t>
             </a:r>
             <a:endParaRPr lang="en-US" sz="1050" dirty="0"/>
           </a:p>
@@ -26353,7 +26245,7 @@
                 <a:ea typeface="Calibri" pitchFamily="34" charset="-122"/>
                 <a:cs typeface="Calibri" pitchFamily="34" charset="-120"/>
               </a:rPr>
-              <a:t>Kepentingan kita sendiri dan orang terdekat harus diberi bobot sama dengan warga jauh di rantai pasok.</a:t>
+              <a:t>Kepentingan pelaku dan pihak terdekatnya harus diberi bobot sama dengan pihak jauh di rantai pasok.</a:t>
             </a:r>
             <a:endParaRPr lang="en-US" sz="1050" dirty="0"/>
           </a:p>
@@ -26434,7 +26326,7 @@
                 <a:ea typeface="Calibri" pitchFamily="34" charset="-122"/>
                 <a:cs typeface="Calibri" pitchFamily="34" charset="-120"/>
               </a:rPr>
-              <a:t>Sulit memberi nilai pada hal yang bernilai intrinsik. Berapa nilai uang yang pantas untuk masa kanak-kanak?</a:t>
+              <a:t>Hal yang bernilai intrinsik sulit dinilai secara moneter, misalnya pengalaman masa kanak-kanak.</a:t>
             </a:r>
             <a:endParaRPr lang="en-US" sz="1050" dirty="0"/>
           </a:p>
@@ -26515,7 +26407,7 @@
                 <a:ea typeface="Calibri" pitchFamily="34" charset="-122"/>
                 <a:cs typeface="Calibri" pitchFamily="34" charset="-120"/>
               </a:rPr>
-              <a:t>Mengejar kebaikan terbesar bagi jumlah terbesar membuat minoritas dan generasi mendatang mudah terlewat.</a:t>
+              <a:t>Pengejaran kebaikan terbesar bagi jumlah terbesar mengabaikan minoritas dan generasi mendatang.</a:t>
             </a:r>
             <a:endParaRPr lang="en-US" sz="1050" dirty="0"/>
           </a:p>
@@ -27066,7 +26958,7 @@
                 <a:ea typeface="Calibri" pitchFamily="34" charset="-122"/>
                 <a:cs typeface="Calibri" pitchFamily="34" charset="-120"/>
               </a:rPr>
-              <a:t>RELEVANSINYA BAGI BISNIS</a:t>
+              <a:t>RELEVANSI BAGI BISNIS</a:t>
             </a:r>
             <a:endParaRPr lang="en-US" sz="950" dirty="0"/>
           </a:p>
@@ -27390,7 +27282,7 @@
                 <a:ea typeface="Calibri" pitchFamily="34" charset="-122"/>
                 <a:cs typeface="Calibri" pitchFamily="34" charset="-120"/>
               </a:rPr>
-              <a:t>TIGA KRITIK</a:t>
+              <a:t>TIGA KEBERATAN</a:t>
             </a:r>
             <a:endParaRPr lang="en-US" sz="950" dirty="0"/>
           </a:p>
@@ -27432,7 +27324,7 @@
                 <a:ea typeface="Calibri" pitchFamily="34" charset="-122"/>
                 <a:cs typeface="Calibri" pitchFamily="34" charset="-120"/>
               </a:rPr>
-              <a:t>Pertama, motivasi dinilai terlalu sempit: perawat yang menemani pasien sekarat karena iba tidak dianggap bermoral. Kedua, akibat diabaikan sama sekali. Ketiga, asumsinya bahwa semua orang mampu bernalar tenang terlalu optimistis.</a:t>
+              <a:t>Pertama, kriteria motivasinya terlalu sempit: perawat yang menemani pasien sekarat atas dasar iba tidak dinilai bermoral. Kedua, akibat diabaikan sepenuhnya. Ketiga, asumsi rasionalitas penuh bersifat idealistis.</a:t>
             </a:r>
             <a:endParaRPr lang="en-US" sz="1150" dirty="0"/>
           </a:p>
@@ -27902,7 +27794,7 @@
                 <a:ea typeface="Calibri" pitchFamily="34" charset="-122"/>
                 <a:cs typeface="Calibri" pitchFamily="34" charset="-120"/>
               </a:rPr>
-              <a:t>HAK DAN KEWAJIBAN, DUA SISI SATU KEPING</a:t>
+              <a:t>KORELASI HAK DAN KEWAJIBAN</a:t>
             </a:r>
             <a:endParaRPr lang="en-US" sz="950" dirty="0"/>
           </a:p>
@@ -27973,7 +27865,7 @@
                 <a:ea typeface="Calibri" pitchFamily="34" charset="-122"/>
                 <a:cs typeface="Calibri" pitchFamily="34" charset="-120"/>
               </a:rPr>
-              <a:t>Hak seseorang menimbulkan kewajiban pada pihak lain. Hak saya atas privasi mewajibkan orang lain menahan diri mengumpulkan informasi pribadi saya tanpa persetujuan.</a:t>
+              <a:t>Hak seseorang menimbulkan kewajiban pada pihak lain. Hak atas privasi mewajibkan pihak lain menahan diri dari pengumpulan informasi pribadi tanpa persetujuan.</a:t>
             </a:r>
             <a:endParaRPr lang="en-US" sz="1150" dirty="0"/>
           </a:p>
@@ -28459,7 +28351,7 @@
                 <a:ea typeface="Calibri" pitchFamily="34" charset="-122"/>
                 <a:cs typeface="Calibri" pitchFamily="34" charset="-120"/>
               </a:rPr>
-              <a:t>Cakupan yang menentukan: perusahaan wajib mencegah dan meredakan dampak buruk yang terkait langsung lewat relasi bisnisnya, sekalipun ia tidak ikut menyebabkannya. Pemasok termasuk di dalamnya.</a:t>
+              <a:t>Cakupan tanggung jawab: perusahaan wajib mencegah dan meredakan dampak buruk yang terkait langsung melalui relasi bisnisnya, sekalipun ia tidak ikut menyebabkannya. Pemasok termasuk di dalamnya.</a:t>
             </a:r>
             <a:endParaRPr lang="en-US" sz="1150" dirty="0"/>
           </a:p>
@@ -28525,7 +28417,7 @@
                 <a:ea typeface="Calibri" pitchFamily="34" charset="-122"/>
                 <a:cs typeface="Calibri" pitchFamily="34" charset="-120"/>
               </a:rPr>
-              <a:t>PASAL YANG PALING SERING TERSENTUH BISNIS</a:t>
+              <a:t>PASAL YANG PALING RELEVAN BAGI BISNIS</a:t>
             </a:r>
             <a:endParaRPr lang="en-US" sz="950" dirty="0"/>
           </a:p>

</xml_diff>

<commit_message>
Credit the full group and add a closing slide
Lists all three authors on the title slide under a Disusun oleh heading,
drops the single-author credit line from the conclusion slide, and adds
a closing slide carrying the thank-you, the discussion question that
previously lived only in the speaker notes, and the group roster.

Deck is now 21 slides; the closing slide needs no speaking time.

Co-Authored-By: Claude Opus 5 <noreply@anthropic.com>
Claude-Session: https://claude.ai/code/session_01AfH2yvsTon6btbkPiZnykT
</commit_message>
<xml_diff>
--- a/business-ethics/Evaluating-Business-Ethics-Hilirisasi-Nikel.pptx
+++ b/business-ethics/Evaluating-Business-Ethics-Hilirisasi-Nikel.pptx
@@ -25,9 +25,10 @@
     <p:sldId id="273" r:id="rId19"/>
     <p:sldId id="274" r:id="rId20"/>
     <p:sldId id="275" r:id="rId21"/>
+    <p:sldId id="276" r:id="rId22"/>
   </p:sldIdLst>
   <p:notesMasterIdLst>
-    <p:notesMasterId r:id="rId22"/>
+    <p:notesMasterId r:id="rId23"/>
   </p:notesMasterIdLst>
   <p:sldSz cx="12192000" cy="6858000"/>
   <p:notesSz cx="6858000" cy="12192000"/>
@@ -1577,7 +1578,7 @@
           <a:p>
             <a:r>
               <a:rPr lang="en-US" dirty="0"/>
-              <a:t>2 menit. Tutup dengan pertanyaan untuk diskusi: struktur dilema yang sama akan berulang pada bauksit, tembaga, dan timah. Siapa menikmati manfaatnya, siapa menanggung bebannya, dan apakah keduanya pihak yang sama?</a:t>
+              <a:t>2 menit. Sampaikan ketiga temuan, lalu ketiga tindak lanjutnya. Pertanyaan diskusinya ditayangkan pada slide berikutnya, jadi jangan dibacakan di sini.</a:t>
             </a:r>
             <a:endParaRPr lang="en-US" dirty="0"/>
           </a:p>
@@ -1601,6 +1602,94 @@
             <a:fld id="{F7021451-1387-4CA6-816F-3879F97B5CBC}" type="slidenum">
               <a:rPr lang="en-US"/>
               <a:t>20</a:t>
+            </a:fld>
+            <a:endParaRPr lang="en-US"/>
+          </a:p>
+        </p:txBody>
+      </p:sp>
+    </p:spTree>
+    <p:extLst>
+      <p:ext uri="{BB962C8B-B14F-4D97-AF65-F5344CB8AC3E}">
+        <p14:creationId xmlns:p14="http://schemas.microsoft.com/office/powerpoint/2010/main" val="1024086991"/>
+      </p:ext>
+    </p:extLst>
+  </p:cSld>
+  <p:clrMapOvr>
+    <a:masterClrMapping/>
+  </p:clrMapOvr>
+</p:notes>
+</file>
+
+<file path=ppt/notesSlides/notesSlide21.xml><?xml version="1.0" encoding="utf-8"?>
+<p:notes xmlns:a="http://schemas.openxmlformats.org/drawingml/2006/main" xmlns:r="http://schemas.openxmlformats.org/officeDocument/2006/relationships" xmlns:p="http://schemas.openxmlformats.org/presentationml/2006/main">
+  <p:cSld>
+    <p:spTree>
+      <p:nvGrpSpPr>
+        <p:cNvPr id="1" name=""/>
+        <p:cNvGrpSpPr/>
+        <p:nvPr/>
+      </p:nvGrpSpPr>
+      <p:grpSpPr>
+        <a:xfrm>
+          <a:off x="0" y="0"/>
+          <a:ext cx="0" cy="0"/>
+          <a:chOff x="0" y="0"/>
+          <a:chExt cx="0" cy="0"/>
+        </a:xfrm>
+      </p:grpSpPr>
+      <p:sp>
+        <p:nvSpPr>
+          <p:cNvPr id="2" name="Slide Image Placeholder 1"/>
+          <p:cNvSpPr>
+            <a:spLocks noGrp="1" noRot="1" noChangeAspect="1"/>
+          </p:cNvSpPr>
+          <p:nvPr>
+            <p:ph type="sldImg"/>
+          </p:nvPr>
+        </p:nvSpPr>
+        <p:spPr/>
+      </p:sp>
+      <p:sp>
+        <p:nvSpPr>
+          <p:cNvPr id="3" name="Notes Placeholder 2"/>
+          <p:cNvSpPr>
+            <a:spLocks noGrp="1"/>
+          </p:cNvSpPr>
+          <p:nvPr>
+            <p:ph type="body" idx="1"/>
+          </p:nvPr>
+        </p:nvSpPr>
+        <p:spPr/>
+        <p:txBody>
+          <a:bodyPr/>
+          <a:lstStyle/>
+          <a:p>
+            <a:r>
+              <a:rPr lang="en-US" dirty="0"/>
+              <a:t>Slide penutup. Bacakan pertanyaan diskusinya, lalu buka forum tanya jawab. Tidak perlu diberi alokasi waktu tersendiri.</a:t>
+            </a:r>
+            <a:endParaRPr lang="en-US" dirty="0"/>
+          </a:p>
+        </p:txBody>
+      </p:sp>
+      <p:sp>
+        <p:nvSpPr>
+          <p:cNvPr id="4" name="Slide Number Placeholder 3"/>
+          <p:cNvSpPr>
+            <a:spLocks noGrp="1"/>
+          </p:cNvSpPr>
+          <p:nvPr>
+            <p:ph type="sldNum" sz="quarter" idx="10"/>
+          </p:nvPr>
+        </p:nvSpPr>
+        <p:spPr/>
+        <p:txBody>
+          <a:bodyPr/>
+          <a:lstStyle/>
+          <a:p>
+            <a:fld id="{F7021451-1387-4CA6-816F-3879F97B5CBC}" type="slidenum">
+              <a:rPr lang="en-US"/>
+              <a:t>21</a:t>
             </a:fld>
             <a:endParaRPr lang="en-US"/>
           </a:p>
@@ -3686,27 +3775,63 @@
         </p:nvSpPr>
         <p:spPr>
           <a:xfrm>
-            <a:off x="566928" y="4315968"/>
-            <a:ext cx="4572000" cy="685800"/>
-          </a:xfrm>
-          <a:prstGeom prst="rect">
-            <a:avLst/>
-          </a:prstGeom>
-          <a:noFill/>
-          <a:ln/>
-        </p:spPr>
-        <p:txBody>
-          <a:bodyPr wrap="square" lIns="0" tIns="0" rIns="0" bIns="0" rtlCol="0" anchor="t"/>
-          <a:lstStyle/>
-          <a:p>
-            <a:pPr indent="0" marL="0">
-              <a:lnSpc>
-                <a:spcPct val="120000"/>
-              </a:lnSpc>
-              <a:buNone/>
-            </a:pPr>
-            <a:r>
-              <a:rPr lang="en-US" sz="1500" b="1" dirty="0">
+            <a:off x="566928" y="3950208"/>
+            <a:ext cx="4572000" cy="219456"/>
+          </a:xfrm>
+          <a:prstGeom prst="rect">
+            <a:avLst/>
+          </a:prstGeom>
+          <a:noFill/>
+          <a:ln/>
+        </p:spPr>
+        <p:txBody>
+          <a:bodyPr wrap="square" lIns="0" tIns="0" rIns="0" bIns="0" rtlCol="0" anchor="ctr"/>
+          <a:lstStyle/>
+          <a:p>
+            <a:pPr indent="0" marL="0">
+              <a:buNone/>
+            </a:pPr>
+            <a:r>
+              <a:rPr lang="en-US" sz="950" b="1" spc="140" kern="0" dirty="0">
+                <a:solidFill>
+                  <a:srgbClr val="B8542A"/>
+                </a:solidFill>
+                <a:latin typeface="Calibri" pitchFamily="34" charset="0"/>
+                <a:ea typeface="Calibri" pitchFamily="34" charset="-122"/>
+                <a:cs typeface="Calibri" pitchFamily="34" charset="-120"/>
+              </a:rPr>
+              <a:t>DISUSUN OLEH</a:t>
+            </a:r>
+            <a:endParaRPr lang="en-US" sz="950" dirty="0"/>
+          </a:p>
+        </p:txBody>
+      </p:sp>
+      <p:sp>
+        <p:nvSpPr>
+          <p:cNvPr id="34" name="Text 32"/>
+          <p:cNvSpPr txBox="1"/>
+          <p:nvPr/>
+        </p:nvSpPr>
+        <p:spPr>
+          <a:xfrm>
+            <a:off x="566928" y="4279392"/>
+            <a:ext cx="4937760" cy="256032"/>
+          </a:xfrm>
+          <a:prstGeom prst="rect">
+            <a:avLst/>
+          </a:prstGeom>
+          <a:noFill/>
+          <a:ln/>
+        </p:spPr>
+        <p:txBody>
+          <a:bodyPr wrap="square" lIns="0" tIns="0" rIns="0" bIns="0" rtlCol="0" anchor="ctr"/>
+          <a:lstStyle/>
+          <a:p>
+            <a:pPr indent="0" marL="0">
+              <a:buNone/>
+            </a:pPr>
+            <a:r>
+              <a:rPr lang="en-US" sz="1350" b="1" dirty="0">
                 <a:solidFill>
                   <a:srgbClr val="FFFFFF"/>
                 </a:solidFill>
@@ -3716,17 +3841,36 @@
               </a:rPr>
               <a:t>Aslih Abnuri</a:t>
             </a:r>
-            <a:endParaRPr lang="en-US" sz="1500" dirty="0"/>
-          </a:p>
-          <a:p>
-            <a:pPr indent="0" marL="0">
-              <a:lnSpc>
-                <a:spcPct val="120000"/>
-              </a:lnSpc>
-              <a:buNone/>
-            </a:pPr>
-            <a:r>
-              <a:rPr lang="en-US" sz="1150" dirty="0">
+            <a:endParaRPr lang="en-US" sz="1350" dirty="0"/>
+          </a:p>
+        </p:txBody>
+      </p:sp>
+      <p:sp>
+        <p:nvSpPr>
+          <p:cNvPr id="35" name="Text 33"/>
+          <p:cNvSpPr txBox="1"/>
+          <p:nvPr/>
+        </p:nvSpPr>
+        <p:spPr>
+          <a:xfrm>
+            <a:off x="566928" y="4526280"/>
+            <a:ext cx="4937760" cy="219456"/>
+          </a:xfrm>
+          <a:prstGeom prst="rect">
+            <a:avLst/>
+          </a:prstGeom>
+          <a:noFill/>
+          <a:ln/>
+        </p:spPr>
+        <p:txBody>
+          <a:bodyPr wrap="square" lIns="0" tIns="0" rIns="0" bIns="0" rtlCol="0" anchor="ctr"/>
+          <a:lstStyle/>
+          <a:p>
+            <a:pPr indent="0" marL="0">
+              <a:buNone/>
+            </a:pPr>
+            <a:r>
+              <a:rPr lang="en-US" sz="1050" dirty="0">
                 <a:solidFill>
                   <a:srgbClr val="97A3AE"/>
                 </a:solidFill>
@@ -3736,19 +3880,175 @@
               </a:rPr>
               <a:t>25/574338/PEK/31801</a:t>
             </a:r>
-            <a:endParaRPr lang="en-US" sz="1500" dirty="0"/>
-          </a:p>
-        </p:txBody>
-      </p:sp>
-      <p:sp>
-        <p:nvSpPr>
-          <p:cNvPr id="34" name="Text 32"/>
-          <p:cNvSpPr txBox="1"/>
-          <p:nvPr/>
-        </p:nvSpPr>
-        <p:spPr>
-          <a:xfrm>
-            <a:off x="566928" y="5897880"/>
+            <a:endParaRPr lang="en-US" sz="1050" dirty="0"/>
+          </a:p>
+        </p:txBody>
+      </p:sp>
+      <p:sp>
+        <p:nvSpPr>
+          <p:cNvPr id="36" name="Text 34"/>
+          <p:cNvSpPr txBox="1"/>
+          <p:nvPr/>
+        </p:nvSpPr>
+        <p:spPr>
+          <a:xfrm>
+            <a:off x="566928" y="4791456"/>
+            <a:ext cx="4937760" cy="256032"/>
+          </a:xfrm>
+          <a:prstGeom prst="rect">
+            <a:avLst/>
+          </a:prstGeom>
+          <a:noFill/>
+          <a:ln/>
+        </p:spPr>
+        <p:txBody>
+          <a:bodyPr wrap="square" lIns="0" tIns="0" rIns="0" bIns="0" rtlCol="0" anchor="ctr"/>
+          <a:lstStyle/>
+          <a:p>
+            <a:pPr indent="0" marL="0">
+              <a:buNone/>
+            </a:pPr>
+            <a:r>
+              <a:rPr lang="en-US" sz="1350" b="1" dirty="0">
+                <a:solidFill>
+                  <a:srgbClr val="FFFFFF"/>
+                </a:solidFill>
+                <a:latin typeface="Cambria" pitchFamily="34" charset="0"/>
+                <a:ea typeface="Cambria" pitchFamily="34" charset="-122"/>
+                <a:cs typeface="Cambria" pitchFamily="34" charset="-120"/>
+              </a:rPr>
+              <a:t>Arfinal Diputra</a:t>
+            </a:r>
+            <a:endParaRPr lang="en-US" sz="1350" dirty="0"/>
+          </a:p>
+        </p:txBody>
+      </p:sp>
+      <p:sp>
+        <p:nvSpPr>
+          <p:cNvPr id="37" name="Text 35"/>
+          <p:cNvSpPr txBox="1"/>
+          <p:nvPr/>
+        </p:nvSpPr>
+        <p:spPr>
+          <a:xfrm>
+            <a:off x="566928" y="5038344"/>
+            <a:ext cx="4937760" cy="219456"/>
+          </a:xfrm>
+          <a:prstGeom prst="rect">
+            <a:avLst/>
+          </a:prstGeom>
+          <a:noFill/>
+          <a:ln/>
+        </p:spPr>
+        <p:txBody>
+          <a:bodyPr wrap="square" lIns="0" tIns="0" rIns="0" bIns="0" rtlCol="0" anchor="ctr"/>
+          <a:lstStyle/>
+          <a:p>
+            <a:pPr indent="0" marL="0">
+              <a:buNone/>
+            </a:pPr>
+            <a:r>
+              <a:rPr lang="en-US" sz="1050" dirty="0">
+                <a:solidFill>
+                  <a:srgbClr val="97A3AE"/>
+                </a:solidFill>
+                <a:latin typeface="Calibri" pitchFamily="34" charset="0"/>
+                <a:ea typeface="Calibri" pitchFamily="34" charset="-122"/>
+                <a:cs typeface="Calibri" pitchFamily="34" charset="-120"/>
+              </a:rPr>
+              <a:t>25/574664/PEK/31914</a:t>
+            </a:r>
+            <a:endParaRPr lang="en-US" sz="1050" dirty="0"/>
+          </a:p>
+        </p:txBody>
+      </p:sp>
+      <p:sp>
+        <p:nvSpPr>
+          <p:cNvPr id="38" name="Text 36"/>
+          <p:cNvSpPr txBox="1"/>
+          <p:nvPr/>
+        </p:nvSpPr>
+        <p:spPr>
+          <a:xfrm>
+            <a:off x="566928" y="5303520"/>
+            <a:ext cx="4937760" cy="256032"/>
+          </a:xfrm>
+          <a:prstGeom prst="rect">
+            <a:avLst/>
+          </a:prstGeom>
+          <a:noFill/>
+          <a:ln/>
+        </p:spPr>
+        <p:txBody>
+          <a:bodyPr wrap="square" lIns="0" tIns="0" rIns="0" bIns="0" rtlCol="0" anchor="ctr"/>
+          <a:lstStyle/>
+          <a:p>
+            <a:pPr indent="0" marL="0">
+              <a:buNone/>
+            </a:pPr>
+            <a:r>
+              <a:rPr lang="en-US" sz="1350" b="1" dirty="0">
+                <a:solidFill>
+                  <a:srgbClr val="FFFFFF"/>
+                </a:solidFill>
+                <a:latin typeface="Cambria" pitchFamily="34" charset="0"/>
+                <a:ea typeface="Cambria" pitchFamily="34" charset="-122"/>
+                <a:cs typeface="Cambria" pitchFamily="34" charset="-120"/>
+              </a:rPr>
+              <a:t>Rohana Dwi Hardianti</a:t>
+            </a:r>
+            <a:endParaRPr lang="en-US" sz="1350" dirty="0"/>
+          </a:p>
+        </p:txBody>
+      </p:sp>
+      <p:sp>
+        <p:nvSpPr>
+          <p:cNvPr id="39" name="Text 37"/>
+          <p:cNvSpPr txBox="1"/>
+          <p:nvPr/>
+        </p:nvSpPr>
+        <p:spPr>
+          <a:xfrm>
+            <a:off x="566928" y="5550408"/>
+            <a:ext cx="4937760" cy="219456"/>
+          </a:xfrm>
+          <a:prstGeom prst="rect">
+            <a:avLst/>
+          </a:prstGeom>
+          <a:noFill/>
+          <a:ln/>
+        </p:spPr>
+        <p:txBody>
+          <a:bodyPr wrap="square" lIns="0" tIns="0" rIns="0" bIns="0" rtlCol="0" anchor="ctr"/>
+          <a:lstStyle/>
+          <a:p>
+            <a:pPr indent="0" marL="0">
+              <a:buNone/>
+            </a:pPr>
+            <a:r>
+              <a:rPr lang="en-US" sz="1050" dirty="0">
+                <a:solidFill>
+                  <a:srgbClr val="97A3AE"/>
+                </a:solidFill>
+                <a:latin typeface="Calibri" pitchFamily="34" charset="0"/>
+                <a:ea typeface="Calibri" pitchFamily="34" charset="-122"/>
+                <a:cs typeface="Calibri" pitchFamily="34" charset="-120"/>
+              </a:rPr>
+              <a:t>25/574077/PEK/31728</a:t>
+            </a:r>
+            <a:endParaRPr lang="en-US" sz="1050" dirty="0"/>
+          </a:p>
+        </p:txBody>
+      </p:sp>
+      <p:sp>
+        <p:nvSpPr>
+          <p:cNvPr id="40" name="Text 38"/>
+          <p:cNvSpPr txBox="1"/>
+          <p:nvPr/>
+        </p:nvSpPr>
+        <p:spPr>
+          <a:xfrm>
+            <a:off x="566928" y="6016752"/>
             <a:ext cx="6949440" cy="548640"/>
           </a:xfrm>
           <a:prstGeom prst="rect">
@@ -20447,42 +20747,521 @@
           </a:p>
         </p:txBody>
       </p:sp>
-      <p:sp>
-        <p:nvSpPr>
-          <p:cNvPr id="32" name="Text 30"/>
-          <p:cNvSpPr txBox="1"/>
-          <p:nvPr/>
-        </p:nvSpPr>
-        <p:spPr>
-          <a:xfrm>
-            <a:off x="566928" y="6455664"/>
-            <a:ext cx="11057839" cy="237744"/>
-          </a:xfrm>
-          <a:prstGeom prst="rect">
-            <a:avLst/>
-          </a:prstGeom>
-          <a:noFill/>
-          <a:ln/>
-        </p:spPr>
-        <p:txBody>
-          <a:bodyPr wrap="square" lIns="0" tIns="0" rIns="0" bIns="0" rtlCol="0" anchor="ctr"/>
-          <a:lstStyle/>
-          <a:p>
-            <a:pPr indent="0" marL="0">
-              <a:buNone/>
-            </a:pPr>
-            <a:r>
-              <a:rPr lang="en-US" sz="950" dirty="0">
-                <a:solidFill>
-                  <a:srgbClr val="6B7684"/>
-                </a:solidFill>
-                <a:latin typeface="Calibri" pitchFamily="34" charset="0"/>
-                <a:ea typeface="Calibri" pitchFamily="34" charset="-122"/>
-                <a:cs typeface="Calibri" pitchFamily="34" charset="-120"/>
-              </a:rPr>
-              <a:t>Aslih Abnuri   |   25/574338/PEK/31801   |   Business Ethics for Sustainability, MBA Universitas Gadjah Mada</a:t>
+    </p:spTree>
+  </p:cSld>
+  <p:clrMapOvr>
+    <a:masterClrMapping/>
+  </p:clrMapOvr>
+</p:sld>
+</file>
+
+<file path=ppt/slides/slide21.xml><?xml version="1.0" encoding="utf-8"?>
+<p:sld xmlns:a="http://schemas.openxmlformats.org/drawingml/2006/main" xmlns:r="http://schemas.openxmlformats.org/officeDocument/2006/relationships" xmlns:p="http://schemas.openxmlformats.org/presentationml/2006/main">
+  <p:cSld name="Slide 21">
+    <p:bg>
+      <p:bgPr>
+        <a:solidFill>
+          <a:srgbClr val="16202A"/>
+        </a:solidFill>
+      </p:bgPr>
+    </p:bg>
+    <p:spTree>
+      <p:nvGrpSpPr>
+        <p:cNvPr id="1" name=""/>
+        <p:cNvGrpSpPr/>
+        <p:nvPr/>
+      </p:nvGrpSpPr>
+      <p:grpSpPr>
+        <a:xfrm>
+          <a:off x="0" y="0"/>
+          <a:ext cx="0" cy="0"/>
+          <a:chOff x="0" y="0"/>
+          <a:chExt cx="0" cy="0"/>
+        </a:xfrm>
+      </p:grpSpPr>
+      <p:sp>
+        <p:nvSpPr>
+          <p:cNvPr id="2" name="Text 0"/>
+          <p:cNvSpPr txBox="1"/>
+          <p:nvPr/>
+        </p:nvSpPr>
+        <p:spPr>
+          <a:xfrm>
+            <a:off x="566928" y="1965960"/>
+            <a:ext cx="6949440" cy="237744"/>
+          </a:xfrm>
+          <a:prstGeom prst="rect">
+            <a:avLst/>
+          </a:prstGeom>
+          <a:noFill/>
+          <a:ln/>
+        </p:spPr>
+        <p:txBody>
+          <a:bodyPr wrap="square" lIns="0" tIns="0" rIns="0" bIns="0" rtlCol="0" anchor="ctr"/>
+          <a:lstStyle/>
+          <a:p>
+            <a:pPr indent="0" marL="0">
+              <a:buNone/>
+            </a:pPr>
+            <a:r>
+              <a:rPr lang="en-US" sz="1050" b="1" spc="140" kern="0" dirty="0">
+                <a:solidFill>
+                  <a:srgbClr val="B8542A"/>
+                </a:solidFill>
+                <a:latin typeface="Calibri" pitchFamily="34" charset="0"/>
+                <a:ea typeface="Calibri" pitchFamily="34" charset="-122"/>
+                <a:cs typeface="Calibri" pitchFamily="34" charset="-120"/>
+              </a:rPr>
+              <a:t>PENUTUP</a:t>
+            </a:r>
+            <a:endParaRPr lang="en-US" sz="1050" dirty="0"/>
+          </a:p>
+        </p:txBody>
+      </p:sp>
+      <p:sp>
+        <p:nvSpPr>
+          <p:cNvPr id="3" name="Text 1"/>
+          <p:cNvSpPr txBox="1"/>
+          <p:nvPr/>
+        </p:nvSpPr>
+        <p:spPr>
+          <a:xfrm>
+            <a:off x="566928" y="2304288"/>
+            <a:ext cx="6949440" cy="1051560"/>
+          </a:xfrm>
+          <a:prstGeom prst="rect">
+            <a:avLst/>
+          </a:prstGeom>
+          <a:noFill/>
+          <a:ln/>
+        </p:spPr>
+        <p:txBody>
+          <a:bodyPr wrap="square" lIns="0" tIns="0" rIns="0" bIns="0" rtlCol="0" anchor="ctr"/>
+          <a:lstStyle/>
+          <a:p>
+            <a:pPr indent="0" marL="0">
+              <a:buNone/>
+            </a:pPr>
+            <a:r>
+              <a:rPr lang="en-US" sz="5200" b="1" dirty="0">
+                <a:solidFill>
+                  <a:srgbClr val="FFFFFF"/>
+                </a:solidFill>
+                <a:latin typeface="Cambria" pitchFamily="34" charset="0"/>
+                <a:ea typeface="Cambria" pitchFamily="34" charset="-122"/>
+                <a:cs typeface="Cambria" pitchFamily="34" charset="-120"/>
+              </a:rPr>
+              <a:t>Terima kasih</a:t>
+            </a:r>
+            <a:endParaRPr lang="en-US" sz="5200" dirty="0"/>
+          </a:p>
+        </p:txBody>
+      </p:sp>
+      <p:sp>
+        <p:nvSpPr>
+          <p:cNvPr id="4" name="Shape 2"/>
+          <p:cNvSpPr/>
+          <p:nvPr/>
+        </p:nvSpPr>
+        <p:spPr>
+          <a:xfrm>
+            <a:off x="566928" y="3657600"/>
+            <a:ext cx="6949440" cy="1737360"/>
+          </a:xfrm>
+          <a:prstGeom prst="roundRect">
+            <a:avLst>
+              <a:gd name="adj" fmla="val 4737"/>
+            </a:avLst>
+          </a:prstGeom>
+          <a:solidFill>
+            <a:srgbClr val="22303D"/>
+          </a:solidFill>
+          <a:ln w="12700">
+            <a:solidFill>
+              <a:srgbClr val="22303D"/>
+            </a:solidFill>
+            <a:prstDash val="solid"/>
+          </a:ln>
+        </p:spPr>
+      </p:sp>
+      <p:sp>
+        <p:nvSpPr>
+          <p:cNvPr id="5" name="Text 3"/>
+          <p:cNvSpPr txBox="1"/>
+          <p:nvPr/>
+        </p:nvSpPr>
+        <p:spPr>
+          <a:xfrm>
+            <a:off x="877824" y="3877056"/>
+            <a:ext cx="6309360" cy="219456"/>
+          </a:xfrm>
+          <a:prstGeom prst="rect">
+            <a:avLst/>
+          </a:prstGeom>
+          <a:noFill/>
+          <a:ln/>
+        </p:spPr>
+        <p:txBody>
+          <a:bodyPr wrap="square" lIns="0" tIns="0" rIns="0" bIns="0" rtlCol="0" anchor="ctr"/>
+          <a:lstStyle/>
+          <a:p>
+            <a:pPr indent="0" marL="0">
+              <a:buNone/>
+            </a:pPr>
+            <a:r>
+              <a:rPr lang="en-US" sz="950" b="1" spc="120" kern="0" dirty="0">
+                <a:solidFill>
+                  <a:srgbClr val="B8542A"/>
+                </a:solidFill>
+                <a:latin typeface="Calibri" pitchFamily="34" charset="0"/>
+                <a:ea typeface="Calibri" pitchFamily="34" charset="-122"/>
+                <a:cs typeface="Calibri" pitchFamily="34" charset="-120"/>
+              </a:rPr>
+              <a:t>PERTANYAAN UNTUK DISKUSI</a:t>
             </a:r>
             <a:endParaRPr lang="en-US" sz="950" dirty="0"/>
+          </a:p>
+        </p:txBody>
+      </p:sp>
+      <p:sp>
+        <p:nvSpPr>
+          <p:cNvPr id="6" name="Text 4"/>
+          <p:cNvSpPr txBox="1"/>
+          <p:nvPr/>
+        </p:nvSpPr>
+        <p:spPr>
+          <a:xfrm>
+            <a:off x="877824" y="4151376"/>
+            <a:ext cx="6327648" cy="1024128"/>
+          </a:xfrm>
+          <a:prstGeom prst="rect">
+            <a:avLst/>
+          </a:prstGeom>
+          <a:noFill/>
+          <a:ln/>
+        </p:spPr>
+        <p:txBody>
+          <a:bodyPr wrap="square" lIns="0" tIns="0" rIns="0" bIns="0" rtlCol="0" anchor="t"/>
+          <a:lstStyle/>
+          <a:p>
+            <a:pPr indent="0" marL="0">
+              <a:lnSpc>
+                <a:spcPct val="114000"/>
+              </a:lnSpc>
+              <a:buNone/>
+            </a:pPr>
+            <a:r>
+              <a:rPr lang="en-US" sz="1500" i="1" dirty="0">
+                <a:solidFill>
+                  <a:srgbClr val="D5DDE4"/>
+                </a:solidFill>
+                <a:latin typeface="Cambria" pitchFamily="34" charset="0"/>
+                <a:ea typeface="Cambria" pitchFamily="34" charset="-122"/>
+                <a:cs typeface="Cambria" pitchFamily="34" charset="-120"/>
+              </a:rPr>
+              <a:t>Struktur dilema yang sama akan berulang pada bauksit, tembaga, dan timah. Siapa yang menikmati manfaatnya, siapa yang menanggung bebannya, dan apakah keduanya pihak yang sama?</a:t>
+            </a:r>
+            <a:endParaRPr lang="en-US" sz="1500" dirty="0"/>
+          </a:p>
+        </p:txBody>
+      </p:sp>
+      <p:sp>
+        <p:nvSpPr>
+          <p:cNvPr id="7" name="Shape 5"/>
+          <p:cNvSpPr/>
+          <p:nvPr/>
+        </p:nvSpPr>
+        <p:spPr>
+          <a:xfrm>
+            <a:off x="8001000" y="1938528"/>
+            <a:ext cx="3657600" cy="3456432"/>
+          </a:xfrm>
+          <a:prstGeom prst="roundRect">
+            <a:avLst>
+              <a:gd name="adj" fmla="val 2381"/>
+            </a:avLst>
+          </a:prstGeom>
+          <a:solidFill>
+            <a:srgbClr val="22303D"/>
+          </a:solidFill>
+          <a:ln w="12700">
+            <a:solidFill>
+              <a:srgbClr val="22303D"/>
+            </a:solidFill>
+            <a:prstDash val="solid"/>
+          </a:ln>
+        </p:spPr>
+      </p:sp>
+      <p:sp>
+        <p:nvSpPr>
+          <p:cNvPr id="8" name="Text 6"/>
+          <p:cNvSpPr txBox="1"/>
+          <p:nvPr/>
+        </p:nvSpPr>
+        <p:spPr>
+          <a:xfrm>
+            <a:off x="8311896" y="2212848"/>
+            <a:ext cx="3108960" cy="219456"/>
+          </a:xfrm>
+          <a:prstGeom prst="rect">
+            <a:avLst/>
+          </a:prstGeom>
+          <a:noFill/>
+          <a:ln/>
+        </p:spPr>
+        <p:txBody>
+          <a:bodyPr wrap="square" lIns="0" tIns="0" rIns="0" bIns="0" rtlCol="0" anchor="ctr"/>
+          <a:lstStyle/>
+          <a:p>
+            <a:pPr indent="0" marL="0">
+              <a:buNone/>
+            </a:pPr>
+            <a:r>
+              <a:rPr lang="en-US" sz="950" b="1" spc="120" kern="0" dirty="0">
+                <a:solidFill>
+                  <a:srgbClr val="97A3AE"/>
+                </a:solidFill>
+                <a:latin typeface="Calibri" pitchFamily="34" charset="0"/>
+                <a:ea typeface="Calibri" pitchFamily="34" charset="-122"/>
+                <a:cs typeface="Calibri" pitchFamily="34" charset="-120"/>
+              </a:rPr>
+              <a:t>DISUSUN OLEH</a:t>
+            </a:r>
+            <a:endParaRPr lang="en-US" sz="950" dirty="0"/>
+          </a:p>
+        </p:txBody>
+      </p:sp>
+      <p:sp>
+        <p:nvSpPr>
+          <p:cNvPr id="9" name="Text 7"/>
+          <p:cNvSpPr txBox="1"/>
+          <p:nvPr/>
+        </p:nvSpPr>
+        <p:spPr>
+          <a:xfrm>
+            <a:off x="8311896" y="2743200"/>
+            <a:ext cx="3108960" cy="274320"/>
+          </a:xfrm>
+          <a:prstGeom prst="rect">
+            <a:avLst/>
+          </a:prstGeom>
+          <a:noFill/>
+          <a:ln/>
+        </p:spPr>
+        <p:txBody>
+          <a:bodyPr wrap="square" lIns="0" tIns="0" rIns="0" bIns="0" rtlCol="0" anchor="ctr"/>
+          <a:lstStyle/>
+          <a:p>
+            <a:pPr indent="0" marL="0">
+              <a:buNone/>
+            </a:pPr>
+            <a:r>
+              <a:rPr lang="en-US" sz="1400" b="1" dirty="0">
+                <a:solidFill>
+                  <a:srgbClr val="FFFFFF"/>
+                </a:solidFill>
+                <a:latin typeface="Cambria" pitchFamily="34" charset="0"/>
+                <a:ea typeface="Cambria" pitchFamily="34" charset="-122"/>
+                <a:cs typeface="Cambria" pitchFamily="34" charset="-120"/>
+              </a:rPr>
+              <a:t>Aslih Abnuri</a:t>
+            </a:r>
+            <a:endParaRPr lang="en-US" sz="1400" dirty="0"/>
+          </a:p>
+        </p:txBody>
+      </p:sp>
+      <p:sp>
+        <p:nvSpPr>
+          <p:cNvPr id="10" name="Text 8"/>
+          <p:cNvSpPr txBox="1"/>
+          <p:nvPr/>
+        </p:nvSpPr>
+        <p:spPr>
+          <a:xfrm>
+            <a:off x="8311896" y="3017520"/>
+            <a:ext cx="3108960" cy="237744"/>
+          </a:xfrm>
+          <a:prstGeom prst="rect">
+            <a:avLst/>
+          </a:prstGeom>
+          <a:noFill/>
+          <a:ln/>
+        </p:spPr>
+        <p:txBody>
+          <a:bodyPr wrap="square" lIns="0" tIns="0" rIns="0" bIns="0" rtlCol="0" anchor="ctr"/>
+          <a:lstStyle/>
+          <a:p>
+            <a:pPr indent="0" marL="0">
+              <a:buNone/>
+            </a:pPr>
+            <a:r>
+              <a:rPr lang="en-US" sz="1100" dirty="0">
+                <a:solidFill>
+                  <a:srgbClr val="97A3AE"/>
+                </a:solidFill>
+                <a:latin typeface="Calibri" pitchFamily="34" charset="0"/>
+                <a:ea typeface="Calibri" pitchFamily="34" charset="-122"/>
+                <a:cs typeface="Calibri" pitchFamily="34" charset="-120"/>
+              </a:rPr>
+              <a:t>25/574338/PEK/31801</a:t>
+            </a:r>
+            <a:endParaRPr lang="en-US" sz="1100" dirty="0"/>
+          </a:p>
+        </p:txBody>
+      </p:sp>
+      <p:sp>
+        <p:nvSpPr>
+          <p:cNvPr id="11" name="Text 9"/>
+          <p:cNvSpPr txBox="1"/>
+          <p:nvPr/>
+        </p:nvSpPr>
+        <p:spPr>
+          <a:xfrm>
+            <a:off x="8311896" y="3584448"/>
+            <a:ext cx="3108960" cy="274320"/>
+          </a:xfrm>
+          <a:prstGeom prst="rect">
+            <a:avLst/>
+          </a:prstGeom>
+          <a:noFill/>
+          <a:ln/>
+        </p:spPr>
+        <p:txBody>
+          <a:bodyPr wrap="square" lIns="0" tIns="0" rIns="0" bIns="0" rtlCol="0" anchor="ctr"/>
+          <a:lstStyle/>
+          <a:p>
+            <a:pPr indent="0" marL="0">
+              <a:buNone/>
+            </a:pPr>
+            <a:r>
+              <a:rPr lang="en-US" sz="1400" b="1" dirty="0">
+                <a:solidFill>
+                  <a:srgbClr val="FFFFFF"/>
+                </a:solidFill>
+                <a:latin typeface="Cambria" pitchFamily="34" charset="0"/>
+                <a:ea typeface="Cambria" pitchFamily="34" charset="-122"/>
+                <a:cs typeface="Cambria" pitchFamily="34" charset="-120"/>
+              </a:rPr>
+              <a:t>Arfinal Diputra</a:t>
+            </a:r>
+            <a:endParaRPr lang="en-US" sz="1400" dirty="0"/>
+          </a:p>
+        </p:txBody>
+      </p:sp>
+      <p:sp>
+        <p:nvSpPr>
+          <p:cNvPr id="12" name="Text 10"/>
+          <p:cNvSpPr txBox="1"/>
+          <p:nvPr/>
+        </p:nvSpPr>
+        <p:spPr>
+          <a:xfrm>
+            <a:off x="8311896" y="3858768"/>
+            <a:ext cx="3108960" cy="237744"/>
+          </a:xfrm>
+          <a:prstGeom prst="rect">
+            <a:avLst/>
+          </a:prstGeom>
+          <a:noFill/>
+          <a:ln/>
+        </p:spPr>
+        <p:txBody>
+          <a:bodyPr wrap="square" lIns="0" tIns="0" rIns="0" bIns="0" rtlCol="0" anchor="ctr"/>
+          <a:lstStyle/>
+          <a:p>
+            <a:pPr indent="0" marL="0">
+              <a:buNone/>
+            </a:pPr>
+            <a:r>
+              <a:rPr lang="en-US" sz="1100" dirty="0">
+                <a:solidFill>
+                  <a:srgbClr val="97A3AE"/>
+                </a:solidFill>
+                <a:latin typeface="Calibri" pitchFamily="34" charset="0"/>
+                <a:ea typeface="Calibri" pitchFamily="34" charset="-122"/>
+                <a:cs typeface="Calibri" pitchFamily="34" charset="-120"/>
+              </a:rPr>
+              <a:t>25/574664/PEK/31914</a:t>
+            </a:r>
+            <a:endParaRPr lang="en-US" sz="1100" dirty="0"/>
+          </a:p>
+        </p:txBody>
+      </p:sp>
+      <p:sp>
+        <p:nvSpPr>
+          <p:cNvPr id="13" name="Text 11"/>
+          <p:cNvSpPr txBox="1"/>
+          <p:nvPr/>
+        </p:nvSpPr>
+        <p:spPr>
+          <a:xfrm>
+            <a:off x="8311896" y="4425696"/>
+            <a:ext cx="3108960" cy="274320"/>
+          </a:xfrm>
+          <a:prstGeom prst="rect">
+            <a:avLst/>
+          </a:prstGeom>
+          <a:noFill/>
+          <a:ln/>
+        </p:spPr>
+        <p:txBody>
+          <a:bodyPr wrap="square" lIns="0" tIns="0" rIns="0" bIns="0" rtlCol="0" anchor="ctr"/>
+          <a:lstStyle/>
+          <a:p>
+            <a:pPr indent="0" marL="0">
+              <a:buNone/>
+            </a:pPr>
+            <a:r>
+              <a:rPr lang="en-US" sz="1400" b="1" dirty="0">
+                <a:solidFill>
+                  <a:srgbClr val="FFFFFF"/>
+                </a:solidFill>
+                <a:latin typeface="Cambria" pitchFamily="34" charset="0"/>
+                <a:ea typeface="Cambria" pitchFamily="34" charset="-122"/>
+                <a:cs typeface="Cambria" pitchFamily="34" charset="-120"/>
+              </a:rPr>
+              <a:t>Rohana Dwi Hardianti</a:t>
+            </a:r>
+            <a:endParaRPr lang="en-US" sz="1400" dirty="0"/>
+          </a:p>
+        </p:txBody>
+      </p:sp>
+      <p:sp>
+        <p:nvSpPr>
+          <p:cNvPr id="14" name="Text 12"/>
+          <p:cNvSpPr txBox="1"/>
+          <p:nvPr/>
+        </p:nvSpPr>
+        <p:spPr>
+          <a:xfrm>
+            <a:off x="8311896" y="4700016"/>
+            <a:ext cx="3108960" cy="237744"/>
+          </a:xfrm>
+          <a:prstGeom prst="rect">
+            <a:avLst/>
+          </a:prstGeom>
+          <a:noFill/>
+          <a:ln/>
+        </p:spPr>
+        <p:txBody>
+          <a:bodyPr wrap="square" lIns="0" tIns="0" rIns="0" bIns="0" rtlCol="0" anchor="ctr"/>
+          <a:lstStyle/>
+          <a:p>
+            <a:pPr indent="0" marL="0">
+              <a:buNone/>
+            </a:pPr>
+            <a:r>
+              <a:rPr lang="en-US" sz="1100" dirty="0">
+                <a:solidFill>
+                  <a:srgbClr val="97A3AE"/>
+                </a:solidFill>
+                <a:latin typeface="Calibri" pitchFamily="34" charset="0"/>
+                <a:ea typeface="Calibri" pitchFamily="34" charset="-122"/>
+                <a:cs typeface="Calibri" pitchFamily="34" charset="-120"/>
+              </a:rPr>
+              <a:t>25/574077/PEK/31728</a:t>
+            </a:r>
+            <a:endParaRPr lang="en-US" sz="1100" dirty="0"/>
           </a:p>
         </p:txBody>
       </p:sp>

</xml_diff>